<commit_message>
docs: refresh submission materials
</commit_message>
<xml_diff>
--- a/docs/stellarwork-pitch-deck.pptx
+++ b/docs/stellarwork-pitch-deck.pptx
@@ -2,22 +2,22 @@
 <file path=ppt/presentation.xml><?xml version="1.0" encoding="utf-8"?>
 <p:presentation xmlns:p="http://schemas.openxmlformats.org/presentationml/2006/main">
   <p:sldMasterIdLst>
-    <p:sldMasterId xmlns:r="http://schemas.openxmlformats.org/officeDocument/2006/relationships" id="2147483648" r:id="R8aac83b3887e4358"/>
+    <p:sldMasterId xmlns:r="http://schemas.openxmlformats.org/officeDocument/2006/relationships" id="2147483648" r:id="Rebf4c25fc54347ec"/>
   </p:sldMasterIdLst>
   <p:notesMasterIdLst>
-    <p:notesMasterId xmlns:r="http://schemas.openxmlformats.org/officeDocument/2006/relationships" r:id="R47a44860ffdf40ee"/>
+    <p:notesMasterId xmlns:r="http://schemas.openxmlformats.org/officeDocument/2006/relationships" r:id="R807c05deaafc4bde"/>
   </p:notesMasterIdLst>
   <p:sldIdLst>
-    <p:sldId xmlns:r="http://schemas.openxmlformats.org/officeDocument/2006/relationships" id="256" r:id="R1e9678cd4e444573"/>
-    <p:sldId xmlns:r="http://schemas.openxmlformats.org/officeDocument/2006/relationships" id="257" r:id="R0cac2c249b9f4880"/>
-    <p:sldId xmlns:r="http://schemas.openxmlformats.org/officeDocument/2006/relationships" id="258" r:id="R4198b7b114b547da"/>
-    <p:sldId xmlns:r="http://schemas.openxmlformats.org/officeDocument/2006/relationships" id="259" r:id="R13e74b228eb14c56"/>
-    <p:sldId xmlns:r="http://schemas.openxmlformats.org/officeDocument/2006/relationships" id="260" r:id="Rf704bd09c4144905"/>
-    <p:sldId xmlns:r="http://schemas.openxmlformats.org/officeDocument/2006/relationships" id="261" r:id="Rd37ba218eea34023"/>
-    <p:sldId xmlns:r="http://schemas.openxmlformats.org/officeDocument/2006/relationships" id="262" r:id="Ra65f61cddc1348f2"/>
-    <p:sldId xmlns:r="http://schemas.openxmlformats.org/officeDocument/2006/relationships" id="263" r:id="R9b2500c1e0f741ef"/>
-    <p:sldId xmlns:r="http://schemas.openxmlformats.org/officeDocument/2006/relationships" id="264" r:id="Rf6df602fc96f4d4e"/>
-    <p:sldId xmlns:r="http://schemas.openxmlformats.org/officeDocument/2006/relationships" id="265" r:id="R44099255f73f41a3"/>
+    <p:sldId xmlns:r="http://schemas.openxmlformats.org/officeDocument/2006/relationships" id="256" r:id="R0cca6b41dc6746fe"/>
+    <p:sldId xmlns:r="http://schemas.openxmlformats.org/officeDocument/2006/relationships" id="257" r:id="R3b783ab8d061477b"/>
+    <p:sldId xmlns:r="http://schemas.openxmlformats.org/officeDocument/2006/relationships" id="258" r:id="R4d9165955aa340bd"/>
+    <p:sldId xmlns:r="http://schemas.openxmlformats.org/officeDocument/2006/relationships" id="259" r:id="R05552f9b438e4ade"/>
+    <p:sldId xmlns:r="http://schemas.openxmlformats.org/officeDocument/2006/relationships" id="260" r:id="R604a7e5439684661"/>
+    <p:sldId xmlns:r="http://schemas.openxmlformats.org/officeDocument/2006/relationships" id="261" r:id="R68ef9cca9c934a78"/>
+    <p:sldId xmlns:r="http://schemas.openxmlformats.org/officeDocument/2006/relationships" id="262" r:id="Rc8ee274ec74146e8"/>
+    <p:sldId xmlns:r="http://schemas.openxmlformats.org/officeDocument/2006/relationships" id="263" r:id="Rd4f91f869d5d4eab"/>
+    <p:sldId xmlns:r="http://schemas.openxmlformats.org/officeDocument/2006/relationships" id="264" r:id="Rf9bad95a95534545"/>
+    <p:sldId xmlns:r="http://schemas.openxmlformats.org/officeDocument/2006/relationships" id="265" r:id="Rdca889eb957b44e9"/>
   </p:sldIdLst>
   <p:sldSz cx="12192000" cy="6858000"/>
   <p:notesSz cx="6858000" cy="9144000"/>
@@ -1109,7 +1109,7 @@
   </p:cSld>
   <p:clrMap bg1="lt1" tx1="dk1" bg2="lt2" tx2="dk2" accent1="accent1" accent2="accent2" accent3="accent3" accent4="accent4" accent5="accent5" accent6="accent6" hlink="hlink" folHlink="folHlink"/>
   <p:sldLayoutIdLst>
-    <p:sldLayoutId xmlns:r="http://schemas.openxmlformats.org/officeDocument/2006/relationships" id="2147483649" r:id="R3bb2d259ef6f4f23"/>
+    <p:sldLayoutId xmlns:r="http://schemas.openxmlformats.org/officeDocument/2006/relationships" id="2147483649" r:id="R3fd0e928dec64039"/>
   </p:sldLayoutIdLst>
   <p:txStyles>
     <p:titleStyle>
@@ -1660,7 +1660,7 @@
           <p:cNvPr id="8" name="">
             <a:extLst xmlns:a="http://schemas.openxmlformats.org/drawingml/2006/main">
               <a:ext uri="{FF2B5EF4-FFF2-40B4-BE49-F238E27FC236}">
-                <a16:creationId xmlns:a16="http://schemas.microsoft.com/office/drawing/2014/main" id="{796CCEAE-C8D2-4088-8207-44D91D6D97C5}"/>
+                <a16:creationId xmlns:a16="http://schemas.microsoft.com/office/drawing/2014/main" id="{9BFCC074-5D3E-4E5F-9836-8F4FAAAB6303}"/>
               </a:ext>
             </a:extLst>
           </p:cNvPr>
@@ -1691,7 +1691,7 @@
           <p:cNvPr id="2" name="">
             <a:extLst xmlns:a="http://schemas.openxmlformats.org/drawingml/2006/main">
               <a:ext uri="{FF2B5EF4-FFF2-40B4-BE49-F238E27FC236}">
-                <a16:creationId xmlns:a16="http://schemas.microsoft.com/office/drawing/2014/main" id="{CA39C682-6ED6-4570-9FEF-24DA197C0204}"/>
+                <a16:creationId xmlns:a16="http://schemas.microsoft.com/office/drawing/2014/main" id="{B405B940-9448-447A-9AFD-9A1A88BCD5C4}"/>
               </a:ext>
             </a:extLst>
           </p:cNvPr>
@@ -1724,7 +1724,7 @@
           <p:cNvPr id="3" name="">
             <a:extLst xmlns:a="http://schemas.openxmlformats.org/drawingml/2006/main">
               <a:ext uri="{FF2B5EF4-FFF2-40B4-BE49-F238E27FC236}">
-                <a16:creationId xmlns:a16="http://schemas.microsoft.com/office/drawing/2014/main" id="{316AB9C9-C655-4FF5-A9CE-6B42076129AD}"/>
+                <a16:creationId xmlns:a16="http://schemas.microsoft.com/office/drawing/2014/main" id="{5416908B-307E-4161-841D-13ACC2633B14}"/>
               </a:ext>
             </a:extLst>
           </p:cNvPr>
@@ -1757,7 +1757,7 @@
           <p:cNvPr id="4" name="">
             <a:extLst xmlns:a="http://schemas.openxmlformats.org/drawingml/2006/main">
               <a:ext uri="{FF2B5EF4-FFF2-40B4-BE49-F238E27FC236}">
-                <a16:creationId xmlns:a16="http://schemas.microsoft.com/office/drawing/2014/main" id="{A3C71BC4-CB3D-4213-AAAA-E6367A2BBC7B}"/>
+                <a16:creationId xmlns:a16="http://schemas.microsoft.com/office/drawing/2014/main" id="{07FFEEFE-3A07-458C-BD9D-5DD26F94BB4A}"/>
               </a:ext>
             </a:extLst>
           </p:cNvPr>
@@ -1807,7 +1807,7 @@
           <p:cNvPr id="5" name="">
             <a:extLst xmlns:a="http://schemas.openxmlformats.org/drawingml/2006/main">
               <a:ext uri="{FF2B5EF4-FFF2-40B4-BE49-F238E27FC236}">
-                <a16:creationId xmlns:a16="http://schemas.microsoft.com/office/drawing/2014/main" id="{8E1F22A2-CC0A-4933-86A8-528E60A7649E}"/>
+                <a16:creationId xmlns:a16="http://schemas.microsoft.com/office/drawing/2014/main" id="{7F3B2DF4-1E34-45E6-8D2A-7C7927151CE8}"/>
               </a:ext>
             </a:extLst>
           </p:cNvPr>
@@ -1874,7 +1874,7 @@
           <p:cNvPr id="6" name="">
             <a:extLst xmlns:a="http://schemas.openxmlformats.org/drawingml/2006/main">
               <a:ext uri="{FF2B5EF4-FFF2-40B4-BE49-F238E27FC236}">
-                <a16:creationId xmlns:a16="http://schemas.microsoft.com/office/drawing/2014/main" id="{C830E242-67E0-4DAA-AA0E-8D1F86D74E5A}"/>
+                <a16:creationId xmlns:a16="http://schemas.microsoft.com/office/drawing/2014/main" id="{BD65B302-37C9-4570-8676-42DD7EFCFB44}"/>
               </a:ext>
             </a:extLst>
           </p:cNvPr>
@@ -1924,7 +1924,7 @@
           <p:cNvPr id="7" name="">
             <a:extLst xmlns:a="http://schemas.openxmlformats.org/drawingml/2006/main">
               <a:ext uri="{FF2B5EF4-FFF2-40B4-BE49-F238E27FC236}">
-                <a16:creationId xmlns:a16="http://schemas.microsoft.com/office/drawing/2014/main" id="{16956B46-15FA-4100-8F14-CFB921A88276}"/>
+                <a16:creationId xmlns:a16="http://schemas.microsoft.com/office/drawing/2014/main" id="{E691B7C6-B5F8-4E57-8749-E7F721BC07E7}"/>
               </a:ext>
             </a:extLst>
           </p:cNvPr>
@@ -1972,7 +1972,7 @@
     </p:spTree>
     <p:extLst>
       <p:ext uri="{BB962C8B-B14F-4D97-AF65-F5344CB8AC3E}">
-        <p14:creationId xmlns:p14="http://schemas.microsoft.com/office/powerpoint/2010/main" val="1051830130"/>
+        <p14:creationId xmlns:p14="http://schemas.microsoft.com/office/powerpoint/2010/main" val="290752411"/>
       </p:ext>
     </p:extLst>
   </p:cSld>
@@ -2003,7 +2003,7 @@
           <p:cNvPr id="23" name="">
             <a:extLst xmlns:a="http://schemas.openxmlformats.org/drawingml/2006/main">
               <a:ext uri="{FF2B5EF4-FFF2-40B4-BE49-F238E27FC236}">
-                <a16:creationId xmlns:a16="http://schemas.microsoft.com/office/drawing/2014/main" id="{33EE37DB-E372-4CAA-A515-79A2AC38E06A}"/>
+                <a16:creationId xmlns:a16="http://schemas.microsoft.com/office/drawing/2014/main" id="{C98CF7D8-4ED9-4A89-98A2-FCE677A291CF}"/>
               </a:ext>
             </a:extLst>
           </p:cNvPr>
@@ -2053,7 +2053,7 @@
           <p:cNvPr id="2" name="">
             <a:extLst xmlns:a="http://schemas.openxmlformats.org/drawingml/2006/main">
               <a:ext uri="{FF2B5EF4-FFF2-40B4-BE49-F238E27FC236}">
-                <a16:creationId xmlns:a16="http://schemas.microsoft.com/office/drawing/2014/main" id="{36D7F8E6-AD48-4FBB-8D5C-58EB5C376FF8}"/>
+                <a16:creationId xmlns:a16="http://schemas.microsoft.com/office/drawing/2014/main" id="{12936ED4-E1C1-4FFB-A2AF-54A640926406}"/>
               </a:ext>
             </a:extLst>
           </p:cNvPr>
@@ -2103,7 +2103,7 @@
           <p:cNvPr id="3" name="">
             <a:extLst xmlns:a="http://schemas.openxmlformats.org/drawingml/2006/main">
               <a:ext uri="{FF2B5EF4-FFF2-40B4-BE49-F238E27FC236}">
-                <a16:creationId xmlns:a16="http://schemas.microsoft.com/office/drawing/2014/main" id="{BC6E0CB3-C90E-410F-81BF-A7895AA737BA}"/>
+                <a16:creationId xmlns:a16="http://schemas.microsoft.com/office/drawing/2014/main" id="{DEB9628C-94FA-44B7-92A1-FF1486919487}"/>
               </a:ext>
             </a:extLst>
           </p:cNvPr>
@@ -2134,7 +2134,7 @@
           <p:cNvPr id="4" name="">
             <a:extLst xmlns:a="http://schemas.openxmlformats.org/drawingml/2006/main">
               <a:ext uri="{FF2B5EF4-FFF2-40B4-BE49-F238E27FC236}">
-                <a16:creationId xmlns:a16="http://schemas.microsoft.com/office/drawing/2014/main" id="{BEC48C61-9BDB-4C8C-8E39-32AA4A5FDA3B}"/>
+                <a16:creationId xmlns:a16="http://schemas.microsoft.com/office/drawing/2014/main" id="{71380A8F-6B8C-45AF-B7A2-13B21459EF4D}"/>
               </a:ext>
             </a:extLst>
           </p:cNvPr>
@@ -2184,7 +2184,7 @@
           <p:cNvPr id="5" name="">
             <a:extLst xmlns:a="http://schemas.openxmlformats.org/drawingml/2006/main">
               <a:ext uri="{FF2B5EF4-FFF2-40B4-BE49-F238E27FC236}">
-                <a16:creationId xmlns:a16="http://schemas.microsoft.com/office/drawing/2014/main" id="{68FBDFD5-5B60-4960-B8A4-1B0197C109B9}"/>
+                <a16:creationId xmlns:a16="http://schemas.microsoft.com/office/drawing/2014/main" id="{5054F632-A8E8-496F-BA22-33D12CBF006C}"/>
               </a:ext>
             </a:extLst>
           </p:cNvPr>
@@ -2234,7 +2234,7 @@
           <p:cNvPr id="6" name="">
             <a:extLst xmlns:a="http://schemas.openxmlformats.org/drawingml/2006/main">
               <a:ext uri="{FF2B5EF4-FFF2-40B4-BE49-F238E27FC236}">
-                <a16:creationId xmlns:a16="http://schemas.microsoft.com/office/drawing/2014/main" id="{F357B77D-B272-4D89-B90E-F150304AA0B7}"/>
+                <a16:creationId xmlns:a16="http://schemas.microsoft.com/office/drawing/2014/main" id="{4C3046E4-11B5-4EE9-9F0E-CB62DC92B3F2}"/>
               </a:ext>
             </a:extLst>
           </p:cNvPr>
@@ -2267,7 +2267,7 @@
           <p:cNvPr id="7" name="">
             <a:extLst xmlns:a="http://schemas.openxmlformats.org/drawingml/2006/main">
               <a:ext uri="{FF2B5EF4-FFF2-40B4-BE49-F238E27FC236}">
-                <a16:creationId xmlns:a16="http://schemas.microsoft.com/office/drawing/2014/main" id="{01383835-93AA-471F-9EF0-19987B65B545}"/>
+                <a16:creationId xmlns:a16="http://schemas.microsoft.com/office/drawing/2014/main" id="{209643BF-A976-4708-A9E0-E9AB2C76EDB5}"/>
               </a:ext>
             </a:extLst>
           </p:cNvPr>
@@ -2317,7 +2317,7 @@
           <p:cNvPr id="8" name="">
             <a:extLst xmlns:a="http://schemas.openxmlformats.org/drawingml/2006/main">
               <a:ext uri="{FF2B5EF4-FFF2-40B4-BE49-F238E27FC236}">
-                <a16:creationId xmlns:a16="http://schemas.microsoft.com/office/drawing/2014/main" id="{B7FB096D-1547-4782-BC3D-022A1CC71319}"/>
+                <a16:creationId xmlns:a16="http://schemas.microsoft.com/office/drawing/2014/main" id="{2340D73E-E715-4B3B-B063-B2D3A4F4FD85}"/>
               </a:ext>
             </a:extLst>
           </p:cNvPr>
@@ -2350,7 +2350,7 @@
           <p:cNvPr id="9" name="">
             <a:extLst xmlns:a="http://schemas.openxmlformats.org/drawingml/2006/main">
               <a:ext uri="{FF2B5EF4-FFF2-40B4-BE49-F238E27FC236}">
-                <a16:creationId xmlns:a16="http://schemas.microsoft.com/office/drawing/2014/main" id="{692218F9-3CEC-400D-8543-BDB6E3F25ED6}"/>
+                <a16:creationId xmlns:a16="http://schemas.microsoft.com/office/drawing/2014/main" id="{5801EF2F-6B8C-42BE-A963-E9640282BB53}"/>
               </a:ext>
             </a:extLst>
           </p:cNvPr>
@@ -2400,7 +2400,7 @@
           <p:cNvPr id="10" name="">
             <a:extLst xmlns:a="http://schemas.openxmlformats.org/drawingml/2006/main">
               <a:ext uri="{FF2B5EF4-FFF2-40B4-BE49-F238E27FC236}">
-                <a16:creationId xmlns:a16="http://schemas.microsoft.com/office/drawing/2014/main" id="{EE3DB6A2-629D-45BF-AC64-DE5639B59CC9}"/>
+                <a16:creationId xmlns:a16="http://schemas.microsoft.com/office/drawing/2014/main" id="{17DE5E1C-B347-4BC6-A9D7-84F3236EAE80}"/>
               </a:ext>
             </a:extLst>
           </p:cNvPr>
@@ -2433,7 +2433,7 @@
           <p:cNvPr id="11" name="">
             <a:extLst xmlns:a="http://schemas.openxmlformats.org/drawingml/2006/main">
               <a:ext uri="{FF2B5EF4-FFF2-40B4-BE49-F238E27FC236}">
-                <a16:creationId xmlns:a16="http://schemas.microsoft.com/office/drawing/2014/main" id="{CB1F8868-B1AE-4E0F-B92A-B3276F1194BB}"/>
+                <a16:creationId xmlns:a16="http://schemas.microsoft.com/office/drawing/2014/main" id="{F0EDF7A1-C791-463E-9F3B-AB0C9237D281}"/>
               </a:ext>
             </a:extLst>
           </p:cNvPr>
@@ -2483,7 +2483,7 @@
           <p:cNvPr id="12" name="">
             <a:extLst xmlns:a="http://schemas.openxmlformats.org/drawingml/2006/main">
               <a:ext uri="{FF2B5EF4-FFF2-40B4-BE49-F238E27FC236}">
-                <a16:creationId xmlns:a16="http://schemas.microsoft.com/office/drawing/2014/main" id="{9B6A16F5-003C-4D19-AB15-BE67E9AA3787}"/>
+                <a16:creationId xmlns:a16="http://schemas.microsoft.com/office/drawing/2014/main" id="{03E51A03-87D3-43D8-B4C2-4066D4A14C96}"/>
               </a:ext>
             </a:extLst>
           </p:cNvPr>
@@ -2516,7 +2516,7 @@
           <p:cNvPr id="13" name="">
             <a:extLst xmlns:a="http://schemas.openxmlformats.org/drawingml/2006/main">
               <a:ext uri="{FF2B5EF4-FFF2-40B4-BE49-F238E27FC236}">
-                <a16:creationId xmlns:a16="http://schemas.microsoft.com/office/drawing/2014/main" id="{916736B2-5162-4523-887A-4AB1462C6E23}"/>
+                <a16:creationId xmlns:a16="http://schemas.microsoft.com/office/drawing/2014/main" id="{A6860E0B-79A2-49EB-B1F5-DFDE5CB31AEF}"/>
               </a:ext>
             </a:extLst>
           </p:cNvPr>
@@ -2566,7 +2566,7 @@
           <p:cNvPr id="14" name="">
             <a:extLst xmlns:a="http://schemas.openxmlformats.org/drawingml/2006/main">
               <a:ext uri="{FF2B5EF4-FFF2-40B4-BE49-F238E27FC236}">
-                <a16:creationId xmlns:a16="http://schemas.microsoft.com/office/drawing/2014/main" id="{9F9BCB32-5EBB-4426-8ED7-CF5F10AA2FFD}"/>
+                <a16:creationId xmlns:a16="http://schemas.microsoft.com/office/drawing/2014/main" id="{A8A93776-B2F5-4DA9-B349-150E2A895538}"/>
               </a:ext>
             </a:extLst>
           </p:cNvPr>
@@ -2599,7 +2599,7 @@
           <p:cNvPr id="15" name="">
             <a:extLst xmlns:a="http://schemas.openxmlformats.org/drawingml/2006/main">
               <a:ext uri="{FF2B5EF4-FFF2-40B4-BE49-F238E27FC236}">
-                <a16:creationId xmlns:a16="http://schemas.microsoft.com/office/drawing/2014/main" id="{7E7FE527-361B-4DF5-8D5D-5A03D93EE038}"/>
+                <a16:creationId xmlns:a16="http://schemas.microsoft.com/office/drawing/2014/main" id="{97FD2511-9C82-4752-BBF7-7629D03395A3}"/>
               </a:ext>
             </a:extLst>
           </p:cNvPr>
@@ -2649,7 +2649,7 @@
           <p:cNvPr id="16" name="">
             <a:extLst xmlns:a="http://schemas.openxmlformats.org/drawingml/2006/main">
               <a:ext uri="{FF2B5EF4-FFF2-40B4-BE49-F238E27FC236}">
-                <a16:creationId xmlns:a16="http://schemas.microsoft.com/office/drawing/2014/main" id="{A6CB89B4-1E04-4742-9D6E-74D93DE34266}"/>
+                <a16:creationId xmlns:a16="http://schemas.microsoft.com/office/drawing/2014/main" id="{D6ADE044-A771-4703-95B9-B5D3E2578E9C}"/>
               </a:ext>
             </a:extLst>
           </p:cNvPr>
@@ -2682,7 +2682,7 @@
           <p:cNvPr id="17" name="">
             <a:extLst xmlns:a="http://schemas.openxmlformats.org/drawingml/2006/main">
               <a:ext uri="{FF2B5EF4-FFF2-40B4-BE49-F238E27FC236}">
-                <a16:creationId xmlns:a16="http://schemas.microsoft.com/office/drawing/2014/main" id="{FC0DE8A4-E6F2-4E19-A0CE-0BCF50C05CF2}"/>
+                <a16:creationId xmlns:a16="http://schemas.microsoft.com/office/drawing/2014/main" id="{42800D21-23F5-479A-860E-54CBC6642BA0}"/>
               </a:ext>
             </a:extLst>
           </p:cNvPr>
@@ -2732,7 +2732,7 @@
           <p:cNvPr id="18" name="">
             <a:extLst xmlns:a="http://schemas.openxmlformats.org/drawingml/2006/main">
               <a:ext uri="{FF2B5EF4-FFF2-40B4-BE49-F238E27FC236}">
-                <a16:creationId xmlns:a16="http://schemas.microsoft.com/office/drawing/2014/main" id="{0A369097-0FCD-49A1-9F8C-E17DC94DF170}"/>
+                <a16:creationId xmlns:a16="http://schemas.microsoft.com/office/drawing/2014/main" id="{2215C690-E45B-4ECC-BFEB-9418B99AED75}"/>
               </a:ext>
             </a:extLst>
           </p:cNvPr>
@@ -2765,7 +2765,7 @@
           <p:cNvPr id="19" name="">
             <a:extLst xmlns:a="http://schemas.openxmlformats.org/drawingml/2006/main">
               <a:ext uri="{FF2B5EF4-FFF2-40B4-BE49-F238E27FC236}">
-                <a16:creationId xmlns:a16="http://schemas.microsoft.com/office/drawing/2014/main" id="{82AC583A-DC68-4036-916A-CD7C91390001}"/>
+                <a16:creationId xmlns:a16="http://schemas.microsoft.com/office/drawing/2014/main" id="{850BA932-D4CA-4D19-B6AA-DB3CD5F61F5D}"/>
               </a:ext>
             </a:extLst>
           </p:cNvPr>
@@ -2815,7 +2815,7 @@
           <p:cNvPr id="20" name="">
             <a:extLst xmlns:a="http://schemas.openxmlformats.org/drawingml/2006/main">
               <a:ext uri="{FF2B5EF4-FFF2-40B4-BE49-F238E27FC236}">
-                <a16:creationId xmlns:a16="http://schemas.microsoft.com/office/drawing/2014/main" id="{2C47D74C-D8AF-4D6E-92B6-668DA337D8D0}"/>
+                <a16:creationId xmlns:a16="http://schemas.microsoft.com/office/drawing/2014/main" id="{5EA86B95-06CA-4233-B2A3-F3B82A00F9A8}"/>
               </a:ext>
             </a:extLst>
           </p:cNvPr>
@@ -2848,7 +2848,7 @@
           <p:cNvPr id="21" name="">
             <a:extLst xmlns:a="http://schemas.openxmlformats.org/drawingml/2006/main">
               <a:ext uri="{FF2B5EF4-FFF2-40B4-BE49-F238E27FC236}">
-                <a16:creationId xmlns:a16="http://schemas.microsoft.com/office/drawing/2014/main" id="{5245836A-AC4E-4038-A0E4-90FEBF319B7F}"/>
+                <a16:creationId xmlns:a16="http://schemas.microsoft.com/office/drawing/2014/main" id="{1F1E4674-417B-4C7E-BCA3-61C7B6A70186}"/>
               </a:ext>
             </a:extLst>
           </p:cNvPr>
@@ -2898,7 +2898,7 @@
           <p:cNvPr id="22" name="">
             <a:extLst xmlns:a="http://schemas.openxmlformats.org/drawingml/2006/main">
               <a:ext uri="{FF2B5EF4-FFF2-40B4-BE49-F238E27FC236}">
-                <a16:creationId xmlns:a16="http://schemas.microsoft.com/office/drawing/2014/main" id="{EDC473C8-F6E4-4F8C-BD57-D4CB7A89FA8B}"/>
+                <a16:creationId xmlns:a16="http://schemas.microsoft.com/office/drawing/2014/main" id="{28BBD7B5-53B0-481D-B320-55E4DCF92691}"/>
               </a:ext>
             </a:extLst>
           </p:cNvPr>
@@ -2946,7 +2946,7 @@
     </p:spTree>
     <p:extLst>
       <p:ext uri="{BB962C8B-B14F-4D97-AF65-F5344CB8AC3E}">
-        <p14:creationId xmlns:p14="http://schemas.microsoft.com/office/powerpoint/2010/main" val="1520982426"/>
+        <p14:creationId xmlns:p14="http://schemas.microsoft.com/office/powerpoint/2010/main" val="281370585"/>
       </p:ext>
     </p:extLst>
   </p:cSld>
@@ -2977,7 +2977,7 @@
           <p:cNvPr id="19" name="">
             <a:extLst xmlns:a="http://schemas.openxmlformats.org/drawingml/2006/main">
               <a:ext uri="{FF2B5EF4-FFF2-40B4-BE49-F238E27FC236}">
-                <a16:creationId xmlns:a16="http://schemas.microsoft.com/office/drawing/2014/main" id="{95185774-7B7B-4FA2-87EC-E976DB04B493}"/>
+                <a16:creationId xmlns:a16="http://schemas.microsoft.com/office/drawing/2014/main" id="{39C97DCF-3705-47D1-9E43-D631C4C3A1B9}"/>
               </a:ext>
             </a:extLst>
           </p:cNvPr>
@@ -3027,7 +3027,7 @@
           <p:cNvPr id="2" name="">
             <a:extLst xmlns:a="http://schemas.openxmlformats.org/drawingml/2006/main">
               <a:ext uri="{FF2B5EF4-FFF2-40B4-BE49-F238E27FC236}">
-                <a16:creationId xmlns:a16="http://schemas.microsoft.com/office/drawing/2014/main" id="{93950012-833C-4E4A-B6DE-9F75D29B39A6}"/>
+                <a16:creationId xmlns:a16="http://schemas.microsoft.com/office/drawing/2014/main" id="{8B10462F-0FAB-40A3-80DD-454E429D9C3C}"/>
               </a:ext>
             </a:extLst>
           </p:cNvPr>
@@ -3077,7 +3077,7 @@
           <p:cNvPr id="3" name="">
             <a:extLst xmlns:a="http://schemas.openxmlformats.org/drawingml/2006/main">
               <a:ext uri="{FF2B5EF4-FFF2-40B4-BE49-F238E27FC236}">
-                <a16:creationId xmlns:a16="http://schemas.microsoft.com/office/drawing/2014/main" id="{3E7B6AE7-7100-44FD-AB07-A86CBA9DF53E}"/>
+                <a16:creationId xmlns:a16="http://schemas.microsoft.com/office/drawing/2014/main" id="{EF537FB4-8C90-41B5-A0E1-5FF4AD5F8F83}"/>
               </a:ext>
             </a:extLst>
           </p:cNvPr>
@@ -3108,7 +3108,7 @@
           <p:cNvPr id="4" name="">
             <a:extLst xmlns:a="http://schemas.openxmlformats.org/drawingml/2006/main">
               <a:ext uri="{FF2B5EF4-FFF2-40B4-BE49-F238E27FC236}">
-                <a16:creationId xmlns:a16="http://schemas.microsoft.com/office/drawing/2014/main" id="{69CFFD74-9471-43E0-AA16-152B1A2071A9}"/>
+                <a16:creationId xmlns:a16="http://schemas.microsoft.com/office/drawing/2014/main" id="{C340D6E3-831F-4631-BE26-2C11150D5D98}"/>
               </a:ext>
             </a:extLst>
           </p:cNvPr>
@@ -3158,7 +3158,7 @@
           <p:cNvPr id="5" name="">
             <a:extLst xmlns:a="http://schemas.openxmlformats.org/drawingml/2006/main">
               <a:ext uri="{FF2B5EF4-FFF2-40B4-BE49-F238E27FC236}">
-                <a16:creationId xmlns:a16="http://schemas.microsoft.com/office/drawing/2014/main" id="{A68D898C-8158-46AC-98C9-C8E1186DA747}"/>
+                <a16:creationId xmlns:a16="http://schemas.microsoft.com/office/drawing/2014/main" id="{F174ACB3-F9C0-4A16-B8B9-668865472765}"/>
               </a:ext>
             </a:extLst>
           </p:cNvPr>
@@ -3208,7 +3208,7 @@
           <p:cNvPr id="6" name="">
             <a:extLst xmlns:a="http://schemas.openxmlformats.org/drawingml/2006/main">
               <a:ext uri="{FF2B5EF4-FFF2-40B4-BE49-F238E27FC236}">
-                <a16:creationId xmlns:a16="http://schemas.microsoft.com/office/drawing/2014/main" id="{0839DFA3-39F5-4FC0-A6F6-0BDEE8E0F2EF}"/>
+                <a16:creationId xmlns:a16="http://schemas.microsoft.com/office/drawing/2014/main" id="{47ED27B2-CD81-4024-9354-B439C48157F1}"/>
               </a:ext>
             </a:extLst>
           </p:cNvPr>
@@ -3241,7 +3241,7 @@
           <p:cNvPr id="7" name="">
             <a:extLst xmlns:a="http://schemas.openxmlformats.org/drawingml/2006/main">
               <a:ext uri="{FF2B5EF4-FFF2-40B4-BE49-F238E27FC236}">
-                <a16:creationId xmlns:a16="http://schemas.microsoft.com/office/drawing/2014/main" id="{04D7D641-CAE4-4B73-A7E9-047BA808A875}"/>
+                <a16:creationId xmlns:a16="http://schemas.microsoft.com/office/drawing/2014/main" id="{EAC8283C-31AE-436C-B65A-49E1EE849457}"/>
               </a:ext>
             </a:extLst>
           </p:cNvPr>
@@ -3291,7 +3291,7 @@
           <p:cNvPr id="8" name="">
             <a:extLst xmlns:a="http://schemas.openxmlformats.org/drawingml/2006/main">
               <a:ext uri="{FF2B5EF4-FFF2-40B4-BE49-F238E27FC236}">
-                <a16:creationId xmlns:a16="http://schemas.microsoft.com/office/drawing/2014/main" id="{89E83EF0-6D87-48A3-AE01-DFFB617D1D69}"/>
+                <a16:creationId xmlns:a16="http://schemas.microsoft.com/office/drawing/2014/main" id="{9330CDBB-5DB1-4D1C-8D00-47E17B0975C3}"/>
               </a:ext>
             </a:extLst>
           </p:cNvPr>
@@ -3341,7 +3341,7 @@
           <p:cNvPr id="9" name="">
             <a:extLst xmlns:a="http://schemas.openxmlformats.org/drawingml/2006/main">
               <a:ext uri="{FF2B5EF4-FFF2-40B4-BE49-F238E27FC236}">
-                <a16:creationId xmlns:a16="http://schemas.microsoft.com/office/drawing/2014/main" id="{0A158E0F-8DCE-42C1-87C2-567FCCAA20A4}"/>
+                <a16:creationId xmlns:a16="http://schemas.microsoft.com/office/drawing/2014/main" id="{033B2702-4988-462E-8233-EEF3FDBAD63C}"/>
               </a:ext>
             </a:extLst>
           </p:cNvPr>
@@ -3391,7 +3391,7 @@
           <p:cNvPr id="10" name="">
             <a:extLst xmlns:a="http://schemas.openxmlformats.org/drawingml/2006/main">
               <a:ext uri="{FF2B5EF4-FFF2-40B4-BE49-F238E27FC236}">
-                <a16:creationId xmlns:a16="http://schemas.microsoft.com/office/drawing/2014/main" id="{980B1C0D-7D52-4BB6-BB56-283A67F0166F}"/>
+                <a16:creationId xmlns:a16="http://schemas.microsoft.com/office/drawing/2014/main" id="{6D25762D-04D3-41BE-8A44-4F7754E66511}"/>
               </a:ext>
             </a:extLst>
           </p:cNvPr>
@@ -3424,7 +3424,7 @@
           <p:cNvPr id="11" name="">
             <a:extLst xmlns:a="http://schemas.openxmlformats.org/drawingml/2006/main">
               <a:ext uri="{FF2B5EF4-FFF2-40B4-BE49-F238E27FC236}">
-                <a16:creationId xmlns:a16="http://schemas.microsoft.com/office/drawing/2014/main" id="{65CDA2D2-EEA0-417E-A0B2-384C8A567204}"/>
+                <a16:creationId xmlns:a16="http://schemas.microsoft.com/office/drawing/2014/main" id="{2315A224-8561-4785-AD35-FC7C01E29628}"/>
               </a:ext>
             </a:extLst>
           </p:cNvPr>
@@ -3474,7 +3474,7 @@
           <p:cNvPr id="12" name="">
             <a:extLst xmlns:a="http://schemas.openxmlformats.org/drawingml/2006/main">
               <a:ext uri="{FF2B5EF4-FFF2-40B4-BE49-F238E27FC236}">
-                <a16:creationId xmlns:a16="http://schemas.microsoft.com/office/drawing/2014/main" id="{CAC4F480-EAC1-4016-93A6-58848FBE3B70}"/>
+                <a16:creationId xmlns:a16="http://schemas.microsoft.com/office/drawing/2014/main" id="{2E76B832-7D33-4367-A8D1-8E55D5DDC8FB}"/>
               </a:ext>
             </a:extLst>
           </p:cNvPr>
@@ -3524,7 +3524,7 @@
           <p:cNvPr id="13" name="">
             <a:extLst xmlns:a="http://schemas.openxmlformats.org/drawingml/2006/main">
               <a:ext uri="{FF2B5EF4-FFF2-40B4-BE49-F238E27FC236}">
-                <a16:creationId xmlns:a16="http://schemas.microsoft.com/office/drawing/2014/main" id="{B07AF896-0583-4BBB-907F-E807AC47CE80}"/>
+                <a16:creationId xmlns:a16="http://schemas.microsoft.com/office/drawing/2014/main" id="{7AFF72DF-8175-49BC-8F00-13FCC5B287C9}"/>
               </a:ext>
             </a:extLst>
           </p:cNvPr>
@@ -3574,7 +3574,7 @@
           <p:cNvPr id="14" name="">
             <a:extLst xmlns:a="http://schemas.openxmlformats.org/drawingml/2006/main">
               <a:ext uri="{FF2B5EF4-FFF2-40B4-BE49-F238E27FC236}">
-                <a16:creationId xmlns:a16="http://schemas.microsoft.com/office/drawing/2014/main" id="{43E3BFEB-A970-4AF8-97D5-A6964099BA7B}"/>
+                <a16:creationId xmlns:a16="http://schemas.microsoft.com/office/drawing/2014/main" id="{8619B686-8B09-4D89-987D-13ECC71B090C}"/>
               </a:ext>
             </a:extLst>
           </p:cNvPr>
@@ -3607,7 +3607,7 @@
           <p:cNvPr id="15" name="">
             <a:extLst xmlns:a="http://schemas.openxmlformats.org/drawingml/2006/main">
               <a:ext uri="{FF2B5EF4-FFF2-40B4-BE49-F238E27FC236}">
-                <a16:creationId xmlns:a16="http://schemas.microsoft.com/office/drawing/2014/main" id="{471F6B92-02EB-4A2C-A6DA-2D9C70EC3552}"/>
+                <a16:creationId xmlns:a16="http://schemas.microsoft.com/office/drawing/2014/main" id="{0DC784C3-7EF7-4B5F-893D-FA847A33F1CC}"/>
               </a:ext>
             </a:extLst>
           </p:cNvPr>
@@ -3657,7 +3657,7 @@
           <p:cNvPr id="16" name="">
             <a:extLst xmlns:a="http://schemas.openxmlformats.org/drawingml/2006/main">
               <a:ext uri="{FF2B5EF4-FFF2-40B4-BE49-F238E27FC236}">
-                <a16:creationId xmlns:a16="http://schemas.microsoft.com/office/drawing/2014/main" id="{F716CC29-6DA3-4142-8BA0-A4BC47FCF0B1}"/>
+                <a16:creationId xmlns:a16="http://schemas.microsoft.com/office/drawing/2014/main" id="{CD447D16-AC1B-465F-83BE-4BA458F81291}"/>
               </a:ext>
             </a:extLst>
           </p:cNvPr>
@@ -3707,7 +3707,7 @@
           <p:cNvPr id="17" name="">
             <a:extLst xmlns:a="http://schemas.openxmlformats.org/drawingml/2006/main">
               <a:ext uri="{FF2B5EF4-FFF2-40B4-BE49-F238E27FC236}">
-                <a16:creationId xmlns:a16="http://schemas.microsoft.com/office/drawing/2014/main" id="{1CE602BD-53D9-4DCF-A691-2B8A979B1346}"/>
+                <a16:creationId xmlns:a16="http://schemas.microsoft.com/office/drawing/2014/main" id="{84DFC72B-5638-46A2-9489-196A9C71985A}"/>
               </a:ext>
             </a:extLst>
           </p:cNvPr>
@@ -3757,7 +3757,7 @@
           <p:cNvPr id="18" name="">
             <a:extLst xmlns:a="http://schemas.openxmlformats.org/drawingml/2006/main">
               <a:ext uri="{FF2B5EF4-FFF2-40B4-BE49-F238E27FC236}">
-                <a16:creationId xmlns:a16="http://schemas.microsoft.com/office/drawing/2014/main" id="{50931802-BC63-41E6-9947-78114ED40935}"/>
+                <a16:creationId xmlns:a16="http://schemas.microsoft.com/office/drawing/2014/main" id="{CA96D71F-1969-4FA2-B375-0E0AD7EE4F00}"/>
               </a:ext>
             </a:extLst>
           </p:cNvPr>
@@ -3805,7 +3805,7 @@
     </p:spTree>
     <p:extLst>
       <p:ext uri="{BB962C8B-B14F-4D97-AF65-F5344CB8AC3E}">
-        <p14:creationId xmlns:p14="http://schemas.microsoft.com/office/powerpoint/2010/main" val="2138637171"/>
+        <p14:creationId xmlns:p14="http://schemas.microsoft.com/office/powerpoint/2010/main" val="1534640058"/>
       </p:ext>
     </p:extLst>
   </p:cSld>
@@ -3836,7 +3836,7 @@
           <p:cNvPr id="27" name="">
             <a:extLst xmlns:a="http://schemas.openxmlformats.org/drawingml/2006/main">
               <a:ext uri="{FF2B5EF4-FFF2-40B4-BE49-F238E27FC236}">
-                <a16:creationId xmlns:a16="http://schemas.microsoft.com/office/drawing/2014/main" id="{A107AE61-0A22-4A8C-95CC-E5E61F9CDF06}"/>
+                <a16:creationId xmlns:a16="http://schemas.microsoft.com/office/drawing/2014/main" id="{1B471070-9F0E-4E87-9258-5E7F3FDDE82C}"/>
               </a:ext>
             </a:extLst>
           </p:cNvPr>
@@ -3886,7 +3886,7 @@
           <p:cNvPr id="2" name="">
             <a:extLst xmlns:a="http://schemas.openxmlformats.org/drawingml/2006/main">
               <a:ext uri="{FF2B5EF4-FFF2-40B4-BE49-F238E27FC236}">
-                <a16:creationId xmlns:a16="http://schemas.microsoft.com/office/drawing/2014/main" id="{B6180932-B4D4-48CC-94B0-AB5F045FD628}"/>
+                <a16:creationId xmlns:a16="http://schemas.microsoft.com/office/drawing/2014/main" id="{6EC81082-8913-40FD-BCF2-A3BA1F6D9598}"/>
               </a:ext>
             </a:extLst>
           </p:cNvPr>
@@ -3936,7 +3936,7 @@
           <p:cNvPr id="3" name="">
             <a:extLst xmlns:a="http://schemas.openxmlformats.org/drawingml/2006/main">
               <a:ext uri="{FF2B5EF4-FFF2-40B4-BE49-F238E27FC236}">
-                <a16:creationId xmlns:a16="http://schemas.microsoft.com/office/drawing/2014/main" id="{122F26DB-2E72-4027-8FF4-19DC7811266E}"/>
+                <a16:creationId xmlns:a16="http://schemas.microsoft.com/office/drawing/2014/main" id="{01FC8B79-7CBD-43E5-B21A-77A50B148DF0}"/>
               </a:ext>
             </a:extLst>
           </p:cNvPr>
@@ -3967,7 +3967,7 @@
           <p:cNvPr id="4" name="">
             <a:extLst xmlns:a="http://schemas.openxmlformats.org/drawingml/2006/main">
               <a:ext uri="{FF2B5EF4-FFF2-40B4-BE49-F238E27FC236}">
-                <a16:creationId xmlns:a16="http://schemas.microsoft.com/office/drawing/2014/main" id="{53F71B80-40C6-4826-A4B8-7F85A05E43A2}"/>
+                <a16:creationId xmlns:a16="http://schemas.microsoft.com/office/drawing/2014/main" id="{DA5A1CBE-D0D3-46B5-9DD5-14740DD2924D}"/>
               </a:ext>
             </a:extLst>
           </p:cNvPr>
@@ -4017,7 +4017,7 @@
           <p:cNvPr id="5" name="">
             <a:extLst xmlns:a="http://schemas.openxmlformats.org/drawingml/2006/main">
               <a:ext uri="{FF2B5EF4-FFF2-40B4-BE49-F238E27FC236}">
-                <a16:creationId xmlns:a16="http://schemas.microsoft.com/office/drawing/2014/main" id="{83C4002B-87E4-471A-AEA2-E5B4F8DE92AA}"/>
+                <a16:creationId xmlns:a16="http://schemas.microsoft.com/office/drawing/2014/main" id="{F02C8152-1795-4BEE-84C7-FC2DDC48D39B}"/>
               </a:ext>
             </a:extLst>
           </p:cNvPr>
@@ -4067,7 +4067,7 @@
           <p:cNvPr id="6" name="">
             <a:extLst xmlns:a="http://schemas.openxmlformats.org/drawingml/2006/main">
               <a:ext uri="{FF2B5EF4-FFF2-40B4-BE49-F238E27FC236}">
-                <a16:creationId xmlns:a16="http://schemas.microsoft.com/office/drawing/2014/main" id="{02B7571A-0D76-4636-928A-1083EF37BF3F}"/>
+                <a16:creationId xmlns:a16="http://schemas.microsoft.com/office/drawing/2014/main" id="{AFC8B2E1-0EBC-4E48-B1BB-4A91D1FC4765}"/>
               </a:ext>
             </a:extLst>
           </p:cNvPr>
@@ -4117,7 +4117,7 @@
           <p:cNvPr id="7" name="">
             <a:extLst xmlns:a="http://schemas.openxmlformats.org/drawingml/2006/main">
               <a:ext uri="{FF2B5EF4-FFF2-40B4-BE49-F238E27FC236}">
-                <a16:creationId xmlns:a16="http://schemas.microsoft.com/office/drawing/2014/main" id="{38F19056-2A1D-4FC3-96A8-0551F9F4DBF8}"/>
+                <a16:creationId xmlns:a16="http://schemas.microsoft.com/office/drawing/2014/main" id="{565DED45-7358-4573-96DC-81CECEEAAB02}"/>
               </a:ext>
             </a:extLst>
           </p:cNvPr>
@@ -4150,7 +4150,7 @@
           <p:cNvPr id="8" name="">
             <a:extLst xmlns:a="http://schemas.openxmlformats.org/drawingml/2006/main">
               <a:ext uri="{FF2B5EF4-FFF2-40B4-BE49-F238E27FC236}">
-                <a16:creationId xmlns:a16="http://schemas.microsoft.com/office/drawing/2014/main" id="{2270A5E3-BABB-4435-8D60-7315053388CC}"/>
+                <a16:creationId xmlns:a16="http://schemas.microsoft.com/office/drawing/2014/main" id="{A8783C9B-2D7A-45F8-BF6D-0E2259D64586}"/>
               </a:ext>
             </a:extLst>
           </p:cNvPr>
@@ -4200,7 +4200,7 @@
           <p:cNvPr id="9" name="">
             <a:extLst xmlns:a="http://schemas.openxmlformats.org/drawingml/2006/main">
               <a:ext uri="{FF2B5EF4-FFF2-40B4-BE49-F238E27FC236}">
-                <a16:creationId xmlns:a16="http://schemas.microsoft.com/office/drawing/2014/main" id="{5C2E4CA8-52BE-4B2F-887A-A3D8D3A04C20}"/>
+                <a16:creationId xmlns:a16="http://schemas.microsoft.com/office/drawing/2014/main" id="{7471028D-94B7-410C-9872-7100FD366C3D}"/>
               </a:ext>
             </a:extLst>
           </p:cNvPr>
@@ -4233,7 +4233,7 @@
           <p:cNvPr id="10" name="">
             <a:extLst xmlns:a="http://schemas.openxmlformats.org/drawingml/2006/main">
               <a:ext uri="{FF2B5EF4-FFF2-40B4-BE49-F238E27FC236}">
-                <a16:creationId xmlns:a16="http://schemas.microsoft.com/office/drawing/2014/main" id="{C6EEB732-5FEE-4F9F-A5F0-7BB67C82BFD4}"/>
+                <a16:creationId xmlns:a16="http://schemas.microsoft.com/office/drawing/2014/main" id="{B2978FF8-9AAE-4DAE-B9DC-D11E272149DF}"/>
               </a:ext>
             </a:extLst>
           </p:cNvPr>
@@ -4283,7 +4283,7 @@
           <p:cNvPr id="11" name="">
             <a:extLst xmlns:a="http://schemas.openxmlformats.org/drawingml/2006/main">
               <a:ext uri="{FF2B5EF4-FFF2-40B4-BE49-F238E27FC236}">
-                <a16:creationId xmlns:a16="http://schemas.microsoft.com/office/drawing/2014/main" id="{103DDAA8-A3C5-4DD8-98BD-6639E75478EB}"/>
+                <a16:creationId xmlns:a16="http://schemas.microsoft.com/office/drawing/2014/main" id="{145B29B9-B28E-4CA6-9ED0-5A38AD9DC003}"/>
               </a:ext>
             </a:extLst>
           </p:cNvPr>
@@ -4316,7 +4316,7 @@
           <p:cNvPr id="12" name="">
             <a:extLst xmlns:a="http://schemas.openxmlformats.org/drawingml/2006/main">
               <a:ext uri="{FF2B5EF4-FFF2-40B4-BE49-F238E27FC236}">
-                <a16:creationId xmlns:a16="http://schemas.microsoft.com/office/drawing/2014/main" id="{1024B36F-3D1A-409C-A69C-31C82A232616}"/>
+                <a16:creationId xmlns:a16="http://schemas.microsoft.com/office/drawing/2014/main" id="{4E249F96-6BEF-4486-B59F-166973F17DC8}"/>
               </a:ext>
             </a:extLst>
           </p:cNvPr>
@@ -4366,7 +4366,7 @@
           <p:cNvPr id="13" name="">
             <a:extLst xmlns:a="http://schemas.openxmlformats.org/drawingml/2006/main">
               <a:ext uri="{FF2B5EF4-FFF2-40B4-BE49-F238E27FC236}">
-                <a16:creationId xmlns:a16="http://schemas.microsoft.com/office/drawing/2014/main" id="{B82AFA40-AD30-4F79-8CF2-03AC658C8DEF}"/>
+                <a16:creationId xmlns:a16="http://schemas.microsoft.com/office/drawing/2014/main" id="{08C5F5CB-D5D8-47E2-B44A-BCD87F028038}"/>
               </a:ext>
             </a:extLst>
           </p:cNvPr>
@@ -4399,7 +4399,7 @@
           <p:cNvPr id="14" name="">
             <a:extLst xmlns:a="http://schemas.openxmlformats.org/drawingml/2006/main">
               <a:ext uri="{FF2B5EF4-FFF2-40B4-BE49-F238E27FC236}">
-                <a16:creationId xmlns:a16="http://schemas.microsoft.com/office/drawing/2014/main" id="{392E6F95-D798-4BF5-92B8-AEFE9FCEDA58}"/>
+                <a16:creationId xmlns:a16="http://schemas.microsoft.com/office/drawing/2014/main" id="{D393E722-6285-4A4B-9356-356EB04041C2}"/>
               </a:ext>
             </a:extLst>
           </p:cNvPr>
@@ -4449,7 +4449,7 @@
           <p:cNvPr id="15" name="">
             <a:extLst xmlns:a="http://schemas.openxmlformats.org/drawingml/2006/main">
               <a:ext uri="{FF2B5EF4-FFF2-40B4-BE49-F238E27FC236}">
-                <a16:creationId xmlns:a16="http://schemas.microsoft.com/office/drawing/2014/main" id="{75FB70B7-32AE-4681-9882-D54923C4E6CC}"/>
+                <a16:creationId xmlns:a16="http://schemas.microsoft.com/office/drawing/2014/main" id="{11EA6CCE-4858-44F6-B3D2-2D978D563E4F}"/>
               </a:ext>
             </a:extLst>
           </p:cNvPr>
@@ -4484,7 +4484,7 @@
           <p:cNvPr id="16" name="">
             <a:extLst xmlns:a="http://schemas.openxmlformats.org/drawingml/2006/main">
               <a:ext uri="{FF2B5EF4-FFF2-40B4-BE49-F238E27FC236}">
-                <a16:creationId xmlns:a16="http://schemas.microsoft.com/office/drawing/2014/main" id="{62FD0A9C-8174-4AD9-BA6B-AF7EF46365F2}"/>
+                <a16:creationId xmlns:a16="http://schemas.microsoft.com/office/drawing/2014/main" id="{0FD4B627-CEB0-4D3E-9BFC-797D938ECA33}"/>
               </a:ext>
             </a:extLst>
           </p:cNvPr>
@@ -4534,7 +4534,7 @@
           <p:cNvPr id="17" name="">
             <a:extLst xmlns:a="http://schemas.openxmlformats.org/drawingml/2006/main">
               <a:ext uri="{FF2B5EF4-FFF2-40B4-BE49-F238E27FC236}">
-                <a16:creationId xmlns:a16="http://schemas.microsoft.com/office/drawing/2014/main" id="{3BAD9006-AC16-4847-84E1-330E3C87D17C}"/>
+                <a16:creationId xmlns:a16="http://schemas.microsoft.com/office/drawing/2014/main" id="{451C26A5-4F70-4413-8ADC-AAB90BAB6B0F}"/>
               </a:ext>
             </a:extLst>
           </p:cNvPr>
@@ -4572,7 +4572,7 @@
           <p:cNvPr id="18" name="">
             <a:extLst xmlns:a="http://schemas.openxmlformats.org/drawingml/2006/main">
               <a:ext uri="{FF2B5EF4-FFF2-40B4-BE49-F238E27FC236}">
-                <a16:creationId xmlns:a16="http://schemas.microsoft.com/office/drawing/2014/main" id="{F7173AE7-0350-497B-ABE4-5FBF032539F5}"/>
+                <a16:creationId xmlns:a16="http://schemas.microsoft.com/office/drawing/2014/main" id="{A6E94C67-C733-4E62-9E46-54AB15CD6A00}"/>
               </a:ext>
             </a:extLst>
           </p:cNvPr>
@@ -4605,7 +4605,7 @@
           <p:cNvPr id="19" name="">
             <a:extLst xmlns:a="http://schemas.openxmlformats.org/drawingml/2006/main">
               <a:ext uri="{FF2B5EF4-FFF2-40B4-BE49-F238E27FC236}">
-                <a16:creationId xmlns:a16="http://schemas.microsoft.com/office/drawing/2014/main" id="{595F6E1C-76A7-4AB3-9298-29980D5CD815}"/>
+                <a16:creationId xmlns:a16="http://schemas.microsoft.com/office/drawing/2014/main" id="{A32CDECD-A2AC-4B4B-8907-E554A4167733}"/>
               </a:ext>
             </a:extLst>
           </p:cNvPr>
@@ -4655,7 +4655,7 @@
           <p:cNvPr id="20" name="">
             <a:extLst xmlns:a="http://schemas.openxmlformats.org/drawingml/2006/main">
               <a:ext uri="{FF2B5EF4-FFF2-40B4-BE49-F238E27FC236}">
-                <a16:creationId xmlns:a16="http://schemas.microsoft.com/office/drawing/2014/main" id="{52F8BF7B-C04F-4912-B647-C89C6F01677F}"/>
+                <a16:creationId xmlns:a16="http://schemas.microsoft.com/office/drawing/2014/main" id="{A8471363-1E1F-4A07-B718-494E092F62FD}"/>
               </a:ext>
             </a:extLst>
           </p:cNvPr>
@@ -4705,7 +4705,7 @@
           <p:cNvPr id="21" name="">
             <a:extLst xmlns:a="http://schemas.openxmlformats.org/drawingml/2006/main">
               <a:ext uri="{FF2B5EF4-FFF2-40B4-BE49-F238E27FC236}">
-                <a16:creationId xmlns:a16="http://schemas.microsoft.com/office/drawing/2014/main" id="{7C1A8C49-BB75-43DB-821B-ED7D882D6872}"/>
+                <a16:creationId xmlns:a16="http://schemas.microsoft.com/office/drawing/2014/main" id="{7C244988-A8C9-4547-920C-865B51DE7BDE}"/>
               </a:ext>
             </a:extLst>
           </p:cNvPr>
@@ -4740,7 +4740,7 @@
           <p:cNvPr id="22" name="">
             <a:extLst xmlns:a="http://schemas.openxmlformats.org/drawingml/2006/main">
               <a:ext uri="{FF2B5EF4-FFF2-40B4-BE49-F238E27FC236}">
-                <a16:creationId xmlns:a16="http://schemas.microsoft.com/office/drawing/2014/main" id="{2CA31625-9171-45B3-8053-702809A7EBD4}"/>
+                <a16:creationId xmlns:a16="http://schemas.microsoft.com/office/drawing/2014/main" id="{D366D4D3-B2D3-41E1-82B5-7DEEA8466CAD}"/>
               </a:ext>
             </a:extLst>
           </p:cNvPr>
@@ -4790,7 +4790,7 @@
           <p:cNvPr id="23" name="">
             <a:extLst xmlns:a="http://schemas.openxmlformats.org/drawingml/2006/main">
               <a:ext uri="{FF2B5EF4-FFF2-40B4-BE49-F238E27FC236}">
-                <a16:creationId xmlns:a16="http://schemas.microsoft.com/office/drawing/2014/main" id="{D8B4570E-BBB3-4128-A6C1-3D7A165593D0}"/>
+                <a16:creationId xmlns:a16="http://schemas.microsoft.com/office/drawing/2014/main" id="{DFC7EC36-F5D1-4C5F-9219-8E541E76ACDB}"/>
               </a:ext>
             </a:extLst>
           </p:cNvPr>
@@ -4828,7 +4828,7 @@
           <p:cNvPr id="24" name="">
             <a:extLst xmlns:a="http://schemas.openxmlformats.org/drawingml/2006/main">
               <a:ext uri="{FF2B5EF4-FFF2-40B4-BE49-F238E27FC236}">
-                <a16:creationId xmlns:a16="http://schemas.microsoft.com/office/drawing/2014/main" id="{397C6F68-3883-48D3-B3AF-06DEDD9491E2}"/>
+                <a16:creationId xmlns:a16="http://schemas.microsoft.com/office/drawing/2014/main" id="{94F475B5-9352-450C-BD58-A01C5E25E2FB}"/>
               </a:ext>
             </a:extLst>
           </p:cNvPr>
@@ -4863,7 +4863,7 @@
           <p:cNvPr id="25" name="">
             <a:extLst xmlns:a="http://schemas.openxmlformats.org/drawingml/2006/main">
               <a:ext uri="{FF2B5EF4-FFF2-40B4-BE49-F238E27FC236}">
-                <a16:creationId xmlns:a16="http://schemas.microsoft.com/office/drawing/2014/main" id="{698317E5-10BC-44FC-BC63-BAA220EDBA8F}"/>
+                <a16:creationId xmlns:a16="http://schemas.microsoft.com/office/drawing/2014/main" id="{64B138C1-D3DE-49B1-BB4B-822C1E601153}"/>
               </a:ext>
             </a:extLst>
           </p:cNvPr>
@@ -4913,7 +4913,7 @@
           <p:cNvPr id="26" name="">
             <a:extLst xmlns:a="http://schemas.openxmlformats.org/drawingml/2006/main">
               <a:ext uri="{FF2B5EF4-FFF2-40B4-BE49-F238E27FC236}">
-                <a16:creationId xmlns:a16="http://schemas.microsoft.com/office/drawing/2014/main" id="{E255FAAF-51C1-4DAA-9FAB-D8B31CADCDBC}"/>
+                <a16:creationId xmlns:a16="http://schemas.microsoft.com/office/drawing/2014/main" id="{0A95EB15-31A2-4A35-80CE-9143E18D7330}"/>
               </a:ext>
             </a:extLst>
           </p:cNvPr>
@@ -4949,7 +4949,7 @@
     </p:spTree>
     <p:extLst>
       <p:ext uri="{BB962C8B-B14F-4D97-AF65-F5344CB8AC3E}">
-        <p14:creationId xmlns:p14="http://schemas.microsoft.com/office/powerpoint/2010/main" val="233685656"/>
+        <p14:creationId xmlns:p14="http://schemas.microsoft.com/office/powerpoint/2010/main" val="989888225"/>
       </p:ext>
     </p:extLst>
   </p:cSld>
@@ -4980,7 +4980,7 @@
           <p:cNvPr id="27" name="">
             <a:extLst xmlns:a="http://schemas.openxmlformats.org/drawingml/2006/main">
               <a:ext uri="{FF2B5EF4-FFF2-40B4-BE49-F238E27FC236}">
-                <a16:creationId xmlns:a16="http://schemas.microsoft.com/office/drawing/2014/main" id="{1911B383-793A-4993-B7E1-A923149DEF41}"/>
+                <a16:creationId xmlns:a16="http://schemas.microsoft.com/office/drawing/2014/main" id="{1DC4BB31-F56D-47A2-A324-D37FE6B9366B}"/>
               </a:ext>
             </a:extLst>
           </p:cNvPr>
@@ -5030,7 +5030,7 @@
           <p:cNvPr id="2" name="">
             <a:extLst xmlns:a="http://schemas.openxmlformats.org/drawingml/2006/main">
               <a:ext uri="{FF2B5EF4-FFF2-40B4-BE49-F238E27FC236}">
-                <a16:creationId xmlns:a16="http://schemas.microsoft.com/office/drawing/2014/main" id="{DCB69BAE-3909-4AD0-8440-1E4420A337E6}"/>
+                <a16:creationId xmlns:a16="http://schemas.microsoft.com/office/drawing/2014/main" id="{4BDE1EA3-656A-444E-8D9A-932072B91A46}"/>
               </a:ext>
             </a:extLst>
           </p:cNvPr>
@@ -5080,7 +5080,7 @@
           <p:cNvPr id="3" name="">
             <a:extLst xmlns:a="http://schemas.openxmlformats.org/drawingml/2006/main">
               <a:ext uri="{FF2B5EF4-FFF2-40B4-BE49-F238E27FC236}">
-                <a16:creationId xmlns:a16="http://schemas.microsoft.com/office/drawing/2014/main" id="{BF8490CA-328D-493C-B7A4-3DC5C39C6DC4}"/>
+                <a16:creationId xmlns:a16="http://schemas.microsoft.com/office/drawing/2014/main" id="{B25EE9EE-9893-4706-938B-5715D951A852}"/>
               </a:ext>
             </a:extLst>
           </p:cNvPr>
@@ -5111,7 +5111,7 @@
           <p:cNvPr id="4" name="">
             <a:extLst xmlns:a="http://schemas.openxmlformats.org/drawingml/2006/main">
               <a:ext uri="{FF2B5EF4-FFF2-40B4-BE49-F238E27FC236}">
-                <a16:creationId xmlns:a16="http://schemas.microsoft.com/office/drawing/2014/main" id="{CC43F102-DE97-46C2-8990-14FA5F89B33F}"/>
+                <a16:creationId xmlns:a16="http://schemas.microsoft.com/office/drawing/2014/main" id="{B43AA2C1-C56D-42CF-AFDC-00ADD1B5B7DC}"/>
               </a:ext>
             </a:extLst>
           </p:cNvPr>
@@ -5161,7 +5161,7 @@
           <p:cNvPr id="5" name="">
             <a:extLst xmlns:a="http://schemas.openxmlformats.org/drawingml/2006/main">
               <a:ext uri="{FF2B5EF4-FFF2-40B4-BE49-F238E27FC236}">
-                <a16:creationId xmlns:a16="http://schemas.microsoft.com/office/drawing/2014/main" id="{7848675B-B3C1-4236-BF5A-8AC6FA205B5F}"/>
+                <a16:creationId xmlns:a16="http://schemas.microsoft.com/office/drawing/2014/main" id="{0840414B-4793-466A-8FE3-9EFFF17EA252}"/>
               </a:ext>
             </a:extLst>
           </p:cNvPr>
@@ -5211,7 +5211,7 @@
           <p:cNvPr id="6" name="">
             <a:extLst xmlns:a="http://schemas.openxmlformats.org/drawingml/2006/main">
               <a:ext uri="{FF2B5EF4-FFF2-40B4-BE49-F238E27FC236}">
-                <a16:creationId xmlns:a16="http://schemas.microsoft.com/office/drawing/2014/main" id="{5EE12EC8-8A3E-4CE6-89BF-AB9D60A9E294}"/>
+                <a16:creationId xmlns:a16="http://schemas.microsoft.com/office/drawing/2014/main" id="{EE31EA9F-7838-4672-B754-EF5CE77E5B4B}"/>
               </a:ext>
             </a:extLst>
           </p:cNvPr>
@@ -5242,7 +5242,7 @@
           <p:cNvPr id="7" name="">
             <a:extLst xmlns:a="http://schemas.openxmlformats.org/drawingml/2006/main">
               <a:ext uri="{FF2B5EF4-FFF2-40B4-BE49-F238E27FC236}">
-                <a16:creationId xmlns:a16="http://schemas.microsoft.com/office/drawing/2014/main" id="{DD14E72C-B41D-4173-BF02-FF88F0E1D244}"/>
+                <a16:creationId xmlns:a16="http://schemas.microsoft.com/office/drawing/2014/main" id="{F551A5AC-B7C6-4D34-A4B4-1385AB167EA1}"/>
               </a:ext>
             </a:extLst>
           </p:cNvPr>
@@ -5275,7 +5275,7 @@
           <p:cNvPr id="8" name="">
             <a:extLst xmlns:a="http://schemas.openxmlformats.org/drawingml/2006/main">
               <a:ext uri="{FF2B5EF4-FFF2-40B4-BE49-F238E27FC236}">
-                <a16:creationId xmlns:a16="http://schemas.microsoft.com/office/drawing/2014/main" id="{6E867479-C84F-49FD-A249-6ABBBCFECCB8}"/>
+                <a16:creationId xmlns:a16="http://schemas.microsoft.com/office/drawing/2014/main" id="{FBB98F12-B54C-42CE-A4DD-63E78A4391D1}"/>
               </a:ext>
             </a:extLst>
           </p:cNvPr>
@@ -5325,7 +5325,7 @@
           <p:cNvPr id="9" name="">
             <a:extLst xmlns:a="http://schemas.openxmlformats.org/drawingml/2006/main">
               <a:ext uri="{FF2B5EF4-FFF2-40B4-BE49-F238E27FC236}">
-                <a16:creationId xmlns:a16="http://schemas.microsoft.com/office/drawing/2014/main" id="{0238F0BB-73EB-4C41-99FA-83098AD28396}"/>
+                <a16:creationId xmlns:a16="http://schemas.microsoft.com/office/drawing/2014/main" id="{A389C950-7D25-4F2B-B198-1172024396E8}"/>
               </a:ext>
             </a:extLst>
           </p:cNvPr>
@@ -5375,7 +5375,7 @@
           <p:cNvPr id="10" name="">
             <a:extLst xmlns:a="http://schemas.openxmlformats.org/drawingml/2006/main">
               <a:ext uri="{FF2B5EF4-FFF2-40B4-BE49-F238E27FC236}">
-                <a16:creationId xmlns:a16="http://schemas.microsoft.com/office/drawing/2014/main" id="{58E34A59-4806-47AB-88A7-4FFE24127383}"/>
+                <a16:creationId xmlns:a16="http://schemas.microsoft.com/office/drawing/2014/main" id="{2B93F1DB-E234-4D28-BF72-3186B6AD40EC}"/>
               </a:ext>
             </a:extLst>
           </p:cNvPr>
@@ -5425,7 +5425,7 @@
           <p:cNvPr id="11" name="">
             <a:extLst xmlns:a="http://schemas.openxmlformats.org/drawingml/2006/main">
               <a:ext uri="{FF2B5EF4-FFF2-40B4-BE49-F238E27FC236}">
-                <a16:creationId xmlns:a16="http://schemas.microsoft.com/office/drawing/2014/main" id="{E344787E-049A-4EDB-875A-773ADB7F447D}"/>
+                <a16:creationId xmlns:a16="http://schemas.microsoft.com/office/drawing/2014/main" id="{14182E28-653E-418C-966B-35A2E5610FEA}"/>
               </a:ext>
             </a:extLst>
           </p:cNvPr>
@@ -5458,7 +5458,7 @@
           <p:cNvPr id="12" name="">
             <a:extLst xmlns:a="http://schemas.openxmlformats.org/drawingml/2006/main">
               <a:ext uri="{FF2B5EF4-FFF2-40B4-BE49-F238E27FC236}">
-                <a16:creationId xmlns:a16="http://schemas.microsoft.com/office/drawing/2014/main" id="{9C481E89-55AF-4C52-9446-EC47AAF49FAB}"/>
+                <a16:creationId xmlns:a16="http://schemas.microsoft.com/office/drawing/2014/main" id="{4260280B-E5B9-4C69-BA49-7EB6B022375F}"/>
               </a:ext>
             </a:extLst>
           </p:cNvPr>
@@ -5508,7 +5508,7 @@
           <p:cNvPr id="13" name="">
             <a:extLst xmlns:a="http://schemas.openxmlformats.org/drawingml/2006/main">
               <a:ext uri="{FF2B5EF4-FFF2-40B4-BE49-F238E27FC236}">
-                <a16:creationId xmlns:a16="http://schemas.microsoft.com/office/drawing/2014/main" id="{239351E9-CEAB-4C02-81DF-E218C0969268}"/>
+                <a16:creationId xmlns:a16="http://schemas.microsoft.com/office/drawing/2014/main" id="{DF4F2EE1-C229-4886-BD8A-1547DEAD5B47}"/>
               </a:ext>
             </a:extLst>
           </p:cNvPr>
@@ -5558,7 +5558,7 @@
           <p:cNvPr id="14" name="">
             <a:extLst xmlns:a="http://schemas.openxmlformats.org/drawingml/2006/main">
               <a:ext uri="{FF2B5EF4-FFF2-40B4-BE49-F238E27FC236}">
-                <a16:creationId xmlns:a16="http://schemas.microsoft.com/office/drawing/2014/main" id="{99296956-B644-4CA2-A20D-323CFF74E2ED}"/>
+                <a16:creationId xmlns:a16="http://schemas.microsoft.com/office/drawing/2014/main" id="{4BEF5080-825C-422C-A0C4-A724E1297BD3}"/>
               </a:ext>
             </a:extLst>
           </p:cNvPr>
@@ -5608,7 +5608,7 @@
           <p:cNvPr id="15" name="">
             <a:extLst xmlns:a="http://schemas.openxmlformats.org/drawingml/2006/main">
               <a:ext uri="{FF2B5EF4-FFF2-40B4-BE49-F238E27FC236}">
-                <a16:creationId xmlns:a16="http://schemas.microsoft.com/office/drawing/2014/main" id="{01068650-858C-40F5-A3B2-4A61922529A1}"/>
+                <a16:creationId xmlns:a16="http://schemas.microsoft.com/office/drawing/2014/main" id="{62AFBEBE-8CED-4F6C-B52F-FB883924F71E}"/>
               </a:ext>
             </a:extLst>
           </p:cNvPr>
@@ -5641,7 +5641,7 @@
           <p:cNvPr id="16" name="">
             <a:extLst xmlns:a="http://schemas.openxmlformats.org/drawingml/2006/main">
               <a:ext uri="{FF2B5EF4-FFF2-40B4-BE49-F238E27FC236}">
-                <a16:creationId xmlns:a16="http://schemas.microsoft.com/office/drawing/2014/main" id="{D19D1991-1834-45AA-A2F4-C7C4669E4E13}"/>
+                <a16:creationId xmlns:a16="http://schemas.microsoft.com/office/drawing/2014/main" id="{F6B23D71-6BEE-41E0-89BC-51740B59717A}"/>
               </a:ext>
             </a:extLst>
           </p:cNvPr>
@@ -5691,7 +5691,7 @@
           <p:cNvPr id="17" name="">
             <a:extLst xmlns:a="http://schemas.openxmlformats.org/drawingml/2006/main">
               <a:ext uri="{FF2B5EF4-FFF2-40B4-BE49-F238E27FC236}">
-                <a16:creationId xmlns:a16="http://schemas.microsoft.com/office/drawing/2014/main" id="{AD8022F1-77B0-4174-A65A-AA96C6E73671}"/>
+                <a16:creationId xmlns:a16="http://schemas.microsoft.com/office/drawing/2014/main" id="{F8602B40-B278-4859-8F8A-FA27F2804E85}"/>
               </a:ext>
             </a:extLst>
           </p:cNvPr>
@@ -5741,7 +5741,7 @@
           <p:cNvPr id="18" name="">
             <a:extLst xmlns:a="http://schemas.openxmlformats.org/drawingml/2006/main">
               <a:ext uri="{FF2B5EF4-FFF2-40B4-BE49-F238E27FC236}">
-                <a16:creationId xmlns:a16="http://schemas.microsoft.com/office/drawing/2014/main" id="{3389854B-2D6A-465F-804F-24FE1E527DD8}"/>
+                <a16:creationId xmlns:a16="http://schemas.microsoft.com/office/drawing/2014/main" id="{3B98332F-70AC-4504-8A2B-3CF1A6DE873D}"/>
               </a:ext>
             </a:extLst>
           </p:cNvPr>
@@ -5791,7 +5791,7 @@
           <p:cNvPr id="19" name="">
             <a:extLst xmlns:a="http://schemas.openxmlformats.org/drawingml/2006/main">
               <a:ext uri="{FF2B5EF4-FFF2-40B4-BE49-F238E27FC236}">
-                <a16:creationId xmlns:a16="http://schemas.microsoft.com/office/drawing/2014/main" id="{5F19EC5E-4DEF-405C-B1B4-22D1B907928E}"/>
+                <a16:creationId xmlns:a16="http://schemas.microsoft.com/office/drawing/2014/main" id="{FB08CBC8-C1BD-4746-85C1-88DD04AE92BF}"/>
               </a:ext>
             </a:extLst>
           </p:cNvPr>
@@ -5824,7 +5824,7 @@
           <p:cNvPr id="20" name="">
             <a:extLst xmlns:a="http://schemas.openxmlformats.org/drawingml/2006/main">
               <a:ext uri="{FF2B5EF4-FFF2-40B4-BE49-F238E27FC236}">
-                <a16:creationId xmlns:a16="http://schemas.microsoft.com/office/drawing/2014/main" id="{19CB3833-3D4C-4773-9E43-5E72A787757B}"/>
+                <a16:creationId xmlns:a16="http://schemas.microsoft.com/office/drawing/2014/main" id="{6795CE9E-0CF5-4C4E-8C7E-02EDD9DDDACE}"/>
               </a:ext>
             </a:extLst>
           </p:cNvPr>
@@ -5874,7 +5874,7 @@
           <p:cNvPr id="21" name="">
             <a:extLst xmlns:a="http://schemas.openxmlformats.org/drawingml/2006/main">
               <a:ext uri="{FF2B5EF4-FFF2-40B4-BE49-F238E27FC236}">
-                <a16:creationId xmlns:a16="http://schemas.microsoft.com/office/drawing/2014/main" id="{9E78FD72-698D-412F-B736-3802265E60CB}"/>
+                <a16:creationId xmlns:a16="http://schemas.microsoft.com/office/drawing/2014/main" id="{84029A93-1A5E-45DA-A042-38C3C46CD2F6}"/>
               </a:ext>
             </a:extLst>
           </p:cNvPr>
@@ -5924,7 +5924,7 @@
           <p:cNvPr id="22" name="">
             <a:extLst xmlns:a="http://schemas.openxmlformats.org/drawingml/2006/main">
               <a:ext uri="{FF2B5EF4-FFF2-40B4-BE49-F238E27FC236}">
-                <a16:creationId xmlns:a16="http://schemas.microsoft.com/office/drawing/2014/main" id="{7215F3C2-D0A5-4D98-B394-7BC53F649BBF}"/>
+                <a16:creationId xmlns:a16="http://schemas.microsoft.com/office/drawing/2014/main" id="{F69555D0-DC3C-4443-B42F-D23CD8326E44}"/>
               </a:ext>
             </a:extLst>
           </p:cNvPr>
@@ -5974,7 +5974,7 @@
           <p:cNvPr id="23" name="">
             <a:extLst xmlns:a="http://schemas.openxmlformats.org/drawingml/2006/main">
               <a:ext uri="{FF2B5EF4-FFF2-40B4-BE49-F238E27FC236}">
-                <a16:creationId xmlns:a16="http://schemas.microsoft.com/office/drawing/2014/main" id="{F0FEBAD5-B866-4DDB-B1B5-2EC64965C2FF}"/>
+                <a16:creationId xmlns:a16="http://schemas.microsoft.com/office/drawing/2014/main" id="{D950B2FC-EF5B-4556-B4DB-923D5CBD67EF}"/>
               </a:ext>
             </a:extLst>
           </p:cNvPr>
@@ -6007,7 +6007,7 @@
           <p:cNvPr id="24" name="">
             <a:extLst xmlns:a="http://schemas.openxmlformats.org/drawingml/2006/main">
               <a:ext uri="{FF2B5EF4-FFF2-40B4-BE49-F238E27FC236}">
-                <a16:creationId xmlns:a16="http://schemas.microsoft.com/office/drawing/2014/main" id="{DF5B16DF-4C58-4755-BE47-2ADE0A36E96E}"/>
+                <a16:creationId xmlns:a16="http://schemas.microsoft.com/office/drawing/2014/main" id="{6D2F8484-F814-42A7-B9D5-7C6CFEC9547E}"/>
               </a:ext>
             </a:extLst>
           </p:cNvPr>
@@ -6057,7 +6057,7 @@
           <p:cNvPr id="25" name="">
             <a:extLst xmlns:a="http://schemas.openxmlformats.org/drawingml/2006/main">
               <a:ext uri="{FF2B5EF4-FFF2-40B4-BE49-F238E27FC236}">
-                <a16:creationId xmlns:a16="http://schemas.microsoft.com/office/drawing/2014/main" id="{9A93442D-655E-4628-8246-36CAAA6222A9}"/>
+                <a16:creationId xmlns:a16="http://schemas.microsoft.com/office/drawing/2014/main" id="{8919F9D4-3A3C-4F0F-B6DB-F74B42CE1930}"/>
               </a:ext>
             </a:extLst>
           </p:cNvPr>
@@ -6107,7 +6107,7 @@
           <p:cNvPr id="26" name="">
             <a:extLst xmlns:a="http://schemas.openxmlformats.org/drawingml/2006/main">
               <a:ext uri="{FF2B5EF4-FFF2-40B4-BE49-F238E27FC236}">
-                <a16:creationId xmlns:a16="http://schemas.microsoft.com/office/drawing/2014/main" id="{CA5E5454-9391-4A38-870F-4D0711F4FCFD}"/>
+                <a16:creationId xmlns:a16="http://schemas.microsoft.com/office/drawing/2014/main" id="{D58F368F-34B9-473C-9B70-4B4E70A4AC0A}"/>
               </a:ext>
             </a:extLst>
           </p:cNvPr>
@@ -6155,7 +6155,7 @@
     </p:spTree>
     <p:extLst>
       <p:ext uri="{BB962C8B-B14F-4D97-AF65-F5344CB8AC3E}">
-        <p14:creationId xmlns:p14="http://schemas.microsoft.com/office/powerpoint/2010/main" val="1640905509"/>
+        <p14:creationId xmlns:p14="http://schemas.microsoft.com/office/powerpoint/2010/main" val="226571227"/>
       </p:ext>
     </p:extLst>
   </p:cSld>
@@ -6186,7 +6186,7 @@
           <p:cNvPr id="22" name="">
             <a:extLst xmlns:a="http://schemas.openxmlformats.org/drawingml/2006/main">
               <a:ext uri="{FF2B5EF4-FFF2-40B4-BE49-F238E27FC236}">
-                <a16:creationId xmlns:a16="http://schemas.microsoft.com/office/drawing/2014/main" id="{CBCFFC7B-D9CE-4DEB-8E63-36B2F2B6AC8D}"/>
+                <a16:creationId xmlns:a16="http://schemas.microsoft.com/office/drawing/2014/main" id="{E566B678-F0C5-4CFE-B11E-1AFBF3D2C08A}"/>
               </a:ext>
             </a:extLst>
           </p:cNvPr>
@@ -6236,7 +6236,7 @@
           <p:cNvPr id="2" name="">
             <a:extLst xmlns:a="http://schemas.openxmlformats.org/drawingml/2006/main">
               <a:ext uri="{FF2B5EF4-FFF2-40B4-BE49-F238E27FC236}">
-                <a16:creationId xmlns:a16="http://schemas.microsoft.com/office/drawing/2014/main" id="{FB1FC170-F2DB-487E-9331-8C3412A8CF08}"/>
+                <a16:creationId xmlns:a16="http://schemas.microsoft.com/office/drawing/2014/main" id="{C25A95CD-A56C-4C11-A8E3-B070DF14E0D9}"/>
               </a:ext>
             </a:extLst>
           </p:cNvPr>
@@ -6286,7 +6286,7 @@
           <p:cNvPr id="3" name="">
             <a:extLst xmlns:a="http://schemas.openxmlformats.org/drawingml/2006/main">
               <a:ext uri="{FF2B5EF4-FFF2-40B4-BE49-F238E27FC236}">
-                <a16:creationId xmlns:a16="http://schemas.microsoft.com/office/drawing/2014/main" id="{D69201F6-0125-481D-9E9D-4DAA1D1F4B53}"/>
+                <a16:creationId xmlns:a16="http://schemas.microsoft.com/office/drawing/2014/main" id="{73CA8665-4EE1-4042-8889-4B210D3843C9}"/>
               </a:ext>
             </a:extLst>
           </p:cNvPr>
@@ -6317,7 +6317,7 @@
           <p:cNvPr id="4" name="">
             <a:extLst xmlns:a="http://schemas.openxmlformats.org/drawingml/2006/main">
               <a:ext uri="{FF2B5EF4-FFF2-40B4-BE49-F238E27FC236}">
-                <a16:creationId xmlns:a16="http://schemas.microsoft.com/office/drawing/2014/main" id="{E8A3F582-A1C8-44FE-BD83-819DA4F50354}"/>
+                <a16:creationId xmlns:a16="http://schemas.microsoft.com/office/drawing/2014/main" id="{DFEAFF4A-A94D-4EB7-9EB5-313448F0D866}"/>
               </a:ext>
             </a:extLst>
           </p:cNvPr>
@@ -6367,7 +6367,7 @@
           <p:cNvPr id="5" name="">
             <a:extLst xmlns:a="http://schemas.openxmlformats.org/drawingml/2006/main">
               <a:ext uri="{FF2B5EF4-FFF2-40B4-BE49-F238E27FC236}">
-                <a16:creationId xmlns:a16="http://schemas.microsoft.com/office/drawing/2014/main" id="{8936BD02-F6FD-465E-827C-9ECFB3228847}"/>
+                <a16:creationId xmlns:a16="http://schemas.microsoft.com/office/drawing/2014/main" id="{5B65DE9F-BD54-4FB9-9BE2-275091F4568F}"/>
               </a:ext>
             </a:extLst>
           </p:cNvPr>
@@ -6417,7 +6417,7 @@
           <p:cNvPr id="6" name="">
             <a:extLst xmlns:a="http://schemas.openxmlformats.org/drawingml/2006/main">
               <a:ext uri="{FF2B5EF4-FFF2-40B4-BE49-F238E27FC236}">
-                <a16:creationId xmlns:a16="http://schemas.microsoft.com/office/drawing/2014/main" id="{ED8C0488-FFE2-4F0B-9469-9A1A1C2B89E1}"/>
+                <a16:creationId xmlns:a16="http://schemas.microsoft.com/office/drawing/2014/main" id="{267ABAA0-E529-4DEE-9D98-C27465F4BDF5}"/>
               </a:ext>
             </a:extLst>
           </p:cNvPr>
@@ -6448,7 +6448,7 @@
           <p:cNvPr id="7" name="">
             <a:extLst xmlns:a="http://schemas.openxmlformats.org/drawingml/2006/main">
               <a:ext uri="{FF2B5EF4-FFF2-40B4-BE49-F238E27FC236}">
-                <a16:creationId xmlns:a16="http://schemas.microsoft.com/office/drawing/2014/main" id="{9D71B5F5-D244-41A3-9982-E22FDBE9BEF5}"/>
+                <a16:creationId xmlns:a16="http://schemas.microsoft.com/office/drawing/2014/main" id="{4AA147C6-214F-4E28-AAC9-AB7ABF022287}"/>
               </a:ext>
             </a:extLst>
           </p:cNvPr>
@@ -6479,7 +6479,7 @@
           <p:cNvPr id="8" name="">
             <a:extLst xmlns:a="http://schemas.openxmlformats.org/drawingml/2006/main">
               <a:ext uri="{FF2B5EF4-FFF2-40B4-BE49-F238E27FC236}">
-                <a16:creationId xmlns:a16="http://schemas.microsoft.com/office/drawing/2014/main" id="{708A4837-4A4B-4E20-BECC-79F0A80DD48C}"/>
+                <a16:creationId xmlns:a16="http://schemas.microsoft.com/office/drawing/2014/main" id="{3DAC067B-DE8A-46FD-A602-D1B25F99D215}"/>
               </a:ext>
             </a:extLst>
           </p:cNvPr>
@@ -6510,7 +6510,7 @@
           <p:cNvPr id="9" name="">
             <a:extLst xmlns:a="http://schemas.openxmlformats.org/drawingml/2006/main">
               <a:ext uri="{FF2B5EF4-FFF2-40B4-BE49-F238E27FC236}">
-                <a16:creationId xmlns:a16="http://schemas.microsoft.com/office/drawing/2014/main" id="{94E93F67-1FEE-497F-B55F-991998984B17}"/>
+                <a16:creationId xmlns:a16="http://schemas.microsoft.com/office/drawing/2014/main" id="{0A7D6EA2-3E00-4B03-8BCF-ACF6E96367F1}"/>
               </a:ext>
             </a:extLst>
           </p:cNvPr>
@@ -6543,7 +6543,7 @@
           <p:cNvPr id="10" name="">
             <a:extLst xmlns:a="http://schemas.openxmlformats.org/drawingml/2006/main">
               <a:ext uri="{FF2B5EF4-FFF2-40B4-BE49-F238E27FC236}">
-                <a16:creationId xmlns:a16="http://schemas.microsoft.com/office/drawing/2014/main" id="{D316D5DB-0E70-470B-BE9F-4F7B9836BD29}"/>
+                <a16:creationId xmlns:a16="http://schemas.microsoft.com/office/drawing/2014/main" id="{15131479-7900-4EBA-B380-CE1287A57931}"/>
               </a:ext>
             </a:extLst>
           </p:cNvPr>
@@ -6593,7 +6593,7 @@
           <p:cNvPr id="11" name="">
             <a:extLst xmlns:a="http://schemas.openxmlformats.org/drawingml/2006/main">
               <a:ext uri="{FF2B5EF4-FFF2-40B4-BE49-F238E27FC236}">
-                <a16:creationId xmlns:a16="http://schemas.microsoft.com/office/drawing/2014/main" id="{2E635412-8D57-45EA-9220-59ED7AB6573B}"/>
+                <a16:creationId xmlns:a16="http://schemas.microsoft.com/office/drawing/2014/main" id="{81BC5B80-2FB3-4CE5-9276-247CEFD0799C}"/>
               </a:ext>
             </a:extLst>
           </p:cNvPr>
@@ -6643,7 +6643,7 @@
           <p:cNvPr id="12" name="">
             <a:extLst xmlns:a="http://schemas.openxmlformats.org/drawingml/2006/main">
               <a:ext uri="{FF2B5EF4-FFF2-40B4-BE49-F238E27FC236}">
-                <a16:creationId xmlns:a16="http://schemas.microsoft.com/office/drawing/2014/main" id="{BCE7F276-C610-4361-92A7-86014E46B0A1}"/>
+                <a16:creationId xmlns:a16="http://schemas.microsoft.com/office/drawing/2014/main" id="{C2E11E3B-67F1-419A-A807-F1DFF008C527}"/>
               </a:ext>
             </a:extLst>
           </p:cNvPr>
@@ -6676,7 +6676,7 @@
           <p:cNvPr id="13" name="">
             <a:extLst xmlns:a="http://schemas.openxmlformats.org/drawingml/2006/main">
               <a:ext uri="{FF2B5EF4-FFF2-40B4-BE49-F238E27FC236}">
-                <a16:creationId xmlns:a16="http://schemas.microsoft.com/office/drawing/2014/main" id="{D8BF21DE-1D4D-42A1-A3F7-AFE2AFFFCF4F}"/>
+                <a16:creationId xmlns:a16="http://schemas.microsoft.com/office/drawing/2014/main" id="{D5F41A9B-6FD9-4BD8-954A-90A185F55F7F}"/>
               </a:ext>
             </a:extLst>
           </p:cNvPr>
@@ -6726,7 +6726,7 @@
           <p:cNvPr id="14" name="">
             <a:extLst xmlns:a="http://schemas.openxmlformats.org/drawingml/2006/main">
               <a:ext uri="{FF2B5EF4-FFF2-40B4-BE49-F238E27FC236}">
-                <a16:creationId xmlns:a16="http://schemas.microsoft.com/office/drawing/2014/main" id="{1B3C5858-0D2C-4CCF-9636-158974B13CAC}"/>
+                <a16:creationId xmlns:a16="http://schemas.microsoft.com/office/drawing/2014/main" id="{2F56DDEF-ED24-4555-9B7B-D76BA11D6D19}"/>
               </a:ext>
             </a:extLst>
           </p:cNvPr>
@@ -6776,7 +6776,7 @@
           <p:cNvPr id="15" name="">
             <a:extLst xmlns:a="http://schemas.openxmlformats.org/drawingml/2006/main">
               <a:ext uri="{FF2B5EF4-FFF2-40B4-BE49-F238E27FC236}">
-                <a16:creationId xmlns:a16="http://schemas.microsoft.com/office/drawing/2014/main" id="{470FAC3D-E7BF-44BC-8395-73BE91963A2F}"/>
+                <a16:creationId xmlns:a16="http://schemas.microsoft.com/office/drawing/2014/main" id="{02B0C7B8-65A4-417F-B7D0-6C47E873551B}"/>
               </a:ext>
             </a:extLst>
           </p:cNvPr>
@@ -6809,7 +6809,7 @@
           <p:cNvPr id="16" name="">
             <a:extLst xmlns:a="http://schemas.openxmlformats.org/drawingml/2006/main">
               <a:ext uri="{FF2B5EF4-FFF2-40B4-BE49-F238E27FC236}">
-                <a16:creationId xmlns:a16="http://schemas.microsoft.com/office/drawing/2014/main" id="{3FCED894-94D1-40FA-B421-14B2C9F4FA8C}"/>
+                <a16:creationId xmlns:a16="http://schemas.microsoft.com/office/drawing/2014/main" id="{44AE31B5-BD4A-4FC6-A897-41C55F8F0725}"/>
               </a:ext>
             </a:extLst>
           </p:cNvPr>
@@ -6859,7 +6859,7 @@
           <p:cNvPr id="17" name="">
             <a:extLst xmlns:a="http://schemas.openxmlformats.org/drawingml/2006/main">
               <a:ext uri="{FF2B5EF4-FFF2-40B4-BE49-F238E27FC236}">
-                <a16:creationId xmlns:a16="http://schemas.microsoft.com/office/drawing/2014/main" id="{26BFB34C-D364-417B-A972-8E5848788053}"/>
+                <a16:creationId xmlns:a16="http://schemas.microsoft.com/office/drawing/2014/main" id="{2FAB66AB-CD49-49BC-90A4-FD0760128239}"/>
               </a:ext>
             </a:extLst>
           </p:cNvPr>
@@ -6909,7 +6909,7 @@
           <p:cNvPr id="18" name="">
             <a:extLst xmlns:a="http://schemas.openxmlformats.org/drawingml/2006/main">
               <a:ext uri="{FF2B5EF4-FFF2-40B4-BE49-F238E27FC236}">
-                <a16:creationId xmlns:a16="http://schemas.microsoft.com/office/drawing/2014/main" id="{2982764E-7D5E-4E62-B9E0-A2D76BBDB8D9}"/>
+                <a16:creationId xmlns:a16="http://schemas.microsoft.com/office/drawing/2014/main" id="{56632250-D063-4569-9058-85BC3B5780DB}"/>
               </a:ext>
             </a:extLst>
           </p:cNvPr>
@@ -6942,7 +6942,7 @@
           <p:cNvPr id="19" name="">
             <a:extLst xmlns:a="http://schemas.openxmlformats.org/drawingml/2006/main">
               <a:ext uri="{FF2B5EF4-FFF2-40B4-BE49-F238E27FC236}">
-                <a16:creationId xmlns:a16="http://schemas.microsoft.com/office/drawing/2014/main" id="{D3724ABA-7413-4948-AE48-D3248A65E0B0}"/>
+                <a16:creationId xmlns:a16="http://schemas.microsoft.com/office/drawing/2014/main" id="{5A200382-36E0-4293-B5A2-F57CE3858424}"/>
               </a:ext>
             </a:extLst>
           </p:cNvPr>
@@ -6992,7 +6992,7 @@
           <p:cNvPr id="20" name="">
             <a:extLst xmlns:a="http://schemas.openxmlformats.org/drawingml/2006/main">
               <a:ext uri="{FF2B5EF4-FFF2-40B4-BE49-F238E27FC236}">
-                <a16:creationId xmlns:a16="http://schemas.microsoft.com/office/drawing/2014/main" id="{DBCB03EA-DD12-49FB-B60E-9E0427F9B696}"/>
+                <a16:creationId xmlns:a16="http://schemas.microsoft.com/office/drawing/2014/main" id="{D33988D7-1509-4C19-A5A7-95A5E3C1D14F}"/>
               </a:ext>
             </a:extLst>
           </p:cNvPr>
@@ -7042,7 +7042,7 @@
           <p:cNvPr id="21" name="">
             <a:extLst xmlns:a="http://schemas.openxmlformats.org/drawingml/2006/main">
               <a:ext uri="{FF2B5EF4-FFF2-40B4-BE49-F238E27FC236}">
-                <a16:creationId xmlns:a16="http://schemas.microsoft.com/office/drawing/2014/main" id="{B6F80185-BD0B-4E86-95E9-002BCF7364D4}"/>
+                <a16:creationId xmlns:a16="http://schemas.microsoft.com/office/drawing/2014/main" id="{C778BAA8-F8A1-4F22-9E57-E89318F84F3E}"/>
               </a:ext>
             </a:extLst>
           </p:cNvPr>
@@ -7090,7 +7090,7 @@
     </p:spTree>
     <p:extLst>
       <p:ext uri="{BB962C8B-B14F-4D97-AF65-F5344CB8AC3E}">
-        <p14:creationId xmlns:p14="http://schemas.microsoft.com/office/powerpoint/2010/main" val="453894382"/>
+        <p14:creationId xmlns:p14="http://schemas.microsoft.com/office/powerpoint/2010/main" val="1130803179"/>
       </p:ext>
     </p:extLst>
   </p:cSld>
@@ -7121,7 +7121,7 @@
           <p:cNvPr id="19" name="">
             <a:extLst xmlns:a="http://schemas.openxmlformats.org/drawingml/2006/main">
               <a:ext uri="{FF2B5EF4-FFF2-40B4-BE49-F238E27FC236}">
-                <a16:creationId xmlns:a16="http://schemas.microsoft.com/office/drawing/2014/main" id="{B05EAFD3-B7BC-4EC7-AB01-1F99DEAFB565}"/>
+                <a16:creationId xmlns:a16="http://schemas.microsoft.com/office/drawing/2014/main" id="{D7BAD04E-7AC3-4E0C-BAC1-6B14B78E7901}"/>
               </a:ext>
             </a:extLst>
           </p:cNvPr>
@@ -7171,7 +7171,7 @@
           <p:cNvPr id="2" name="">
             <a:extLst xmlns:a="http://schemas.openxmlformats.org/drawingml/2006/main">
               <a:ext uri="{FF2B5EF4-FFF2-40B4-BE49-F238E27FC236}">
-                <a16:creationId xmlns:a16="http://schemas.microsoft.com/office/drawing/2014/main" id="{48B83034-E72D-49C6-9099-D0AA48E6E54E}"/>
+                <a16:creationId xmlns:a16="http://schemas.microsoft.com/office/drawing/2014/main" id="{5BEF5237-45F8-404E-B9D7-B66C8AD21335}"/>
               </a:ext>
             </a:extLst>
           </p:cNvPr>
@@ -7221,7 +7221,7 @@
           <p:cNvPr id="3" name="">
             <a:extLst xmlns:a="http://schemas.openxmlformats.org/drawingml/2006/main">
               <a:ext uri="{FF2B5EF4-FFF2-40B4-BE49-F238E27FC236}">
-                <a16:creationId xmlns:a16="http://schemas.microsoft.com/office/drawing/2014/main" id="{A48600FD-9086-4119-B403-DA0FED35DC97}"/>
+                <a16:creationId xmlns:a16="http://schemas.microsoft.com/office/drawing/2014/main" id="{C43F5035-73B7-4F5D-80B5-264AA68EEB7F}"/>
               </a:ext>
             </a:extLst>
           </p:cNvPr>
@@ -7252,7 +7252,7 @@
           <p:cNvPr id="4" name="">
             <a:extLst xmlns:a="http://schemas.openxmlformats.org/drawingml/2006/main">
               <a:ext uri="{FF2B5EF4-FFF2-40B4-BE49-F238E27FC236}">
-                <a16:creationId xmlns:a16="http://schemas.microsoft.com/office/drawing/2014/main" id="{E06E5A6E-67FF-4540-9DE8-9571B859B80B}"/>
+                <a16:creationId xmlns:a16="http://schemas.microsoft.com/office/drawing/2014/main" id="{66DF056B-FAE2-49CF-8BC1-4C630194DE8C}"/>
               </a:ext>
             </a:extLst>
           </p:cNvPr>
@@ -7302,7 +7302,7 @@
           <p:cNvPr id="5" name="">
             <a:extLst xmlns:a="http://schemas.openxmlformats.org/drawingml/2006/main">
               <a:ext uri="{FF2B5EF4-FFF2-40B4-BE49-F238E27FC236}">
-                <a16:creationId xmlns:a16="http://schemas.microsoft.com/office/drawing/2014/main" id="{51026DED-5106-44B0-984F-166C408EA81E}"/>
+                <a16:creationId xmlns:a16="http://schemas.microsoft.com/office/drawing/2014/main" id="{C2C1CF11-1652-4AA2-9C2E-80DC43346296}"/>
               </a:ext>
             </a:extLst>
           </p:cNvPr>
@@ -7352,7 +7352,7 @@
           <p:cNvPr id="6" name="">
             <a:extLst xmlns:a="http://schemas.openxmlformats.org/drawingml/2006/main">
               <a:ext uri="{FF2B5EF4-FFF2-40B4-BE49-F238E27FC236}">
-                <a16:creationId xmlns:a16="http://schemas.microsoft.com/office/drawing/2014/main" id="{16EC86D7-4748-4F15-91FB-B5D0A1BA38C2}"/>
+                <a16:creationId xmlns:a16="http://schemas.microsoft.com/office/drawing/2014/main" id="{F26DE4F5-B9F9-4D91-B40F-09ACC3950A8D}"/>
               </a:ext>
             </a:extLst>
           </p:cNvPr>
@@ -7385,7 +7385,7 @@
           <p:cNvPr id="7" name="">
             <a:extLst xmlns:a="http://schemas.openxmlformats.org/drawingml/2006/main">
               <a:ext uri="{FF2B5EF4-FFF2-40B4-BE49-F238E27FC236}">
-                <a16:creationId xmlns:a16="http://schemas.microsoft.com/office/drawing/2014/main" id="{544DD4FB-47C9-48D4-822D-6E10E08E8868}"/>
+                <a16:creationId xmlns:a16="http://schemas.microsoft.com/office/drawing/2014/main" id="{7A2B74F7-80EC-4398-9D78-7F513DED340A}"/>
               </a:ext>
             </a:extLst>
           </p:cNvPr>
@@ -7435,7 +7435,7 @@
           <p:cNvPr id="8" name="">
             <a:extLst xmlns:a="http://schemas.openxmlformats.org/drawingml/2006/main">
               <a:ext uri="{FF2B5EF4-FFF2-40B4-BE49-F238E27FC236}">
-                <a16:creationId xmlns:a16="http://schemas.microsoft.com/office/drawing/2014/main" id="{7710871A-3984-47B7-B8D8-EE5768BD658F}"/>
+                <a16:creationId xmlns:a16="http://schemas.microsoft.com/office/drawing/2014/main" id="{6DC71A4D-2CD5-48B4-9F64-0C6BC5733819}"/>
               </a:ext>
             </a:extLst>
           </p:cNvPr>
@@ -7485,7 +7485,7 @@
           <p:cNvPr id="9" name="">
             <a:extLst xmlns:a="http://schemas.openxmlformats.org/drawingml/2006/main">
               <a:ext uri="{FF2B5EF4-FFF2-40B4-BE49-F238E27FC236}">
-                <a16:creationId xmlns:a16="http://schemas.microsoft.com/office/drawing/2014/main" id="{4AB30A3E-43E4-4A81-917E-77347DCEFF99}"/>
+                <a16:creationId xmlns:a16="http://schemas.microsoft.com/office/drawing/2014/main" id="{AA7D4B4A-05BE-40CA-900F-3333ED546521}"/>
               </a:ext>
             </a:extLst>
           </p:cNvPr>
@@ -7518,7 +7518,7 @@
           <p:cNvPr id="10" name="">
             <a:extLst xmlns:a="http://schemas.openxmlformats.org/drawingml/2006/main">
               <a:ext uri="{FF2B5EF4-FFF2-40B4-BE49-F238E27FC236}">
-                <a16:creationId xmlns:a16="http://schemas.microsoft.com/office/drawing/2014/main" id="{FC9F986A-FDA1-47F4-9490-2719061DF37A}"/>
+                <a16:creationId xmlns:a16="http://schemas.microsoft.com/office/drawing/2014/main" id="{C1748C67-B444-46D0-A282-EBFB5F5BD89B}"/>
               </a:ext>
             </a:extLst>
           </p:cNvPr>
@@ -7568,7 +7568,7 @@
           <p:cNvPr id="11" name="">
             <a:extLst xmlns:a="http://schemas.openxmlformats.org/drawingml/2006/main">
               <a:ext uri="{FF2B5EF4-FFF2-40B4-BE49-F238E27FC236}">
-                <a16:creationId xmlns:a16="http://schemas.microsoft.com/office/drawing/2014/main" id="{71944141-5384-4597-BF88-00EFCAC32F7D}"/>
+                <a16:creationId xmlns:a16="http://schemas.microsoft.com/office/drawing/2014/main" id="{6EDD176A-C00C-4091-BD72-F28B2242225A}"/>
               </a:ext>
             </a:extLst>
           </p:cNvPr>
@@ -7618,7 +7618,7 @@
           <p:cNvPr id="12" name="">
             <a:extLst xmlns:a="http://schemas.openxmlformats.org/drawingml/2006/main">
               <a:ext uri="{FF2B5EF4-FFF2-40B4-BE49-F238E27FC236}">
-                <a16:creationId xmlns:a16="http://schemas.microsoft.com/office/drawing/2014/main" id="{9219CAEF-B26F-40CF-A672-9EC5913907FB}"/>
+                <a16:creationId xmlns:a16="http://schemas.microsoft.com/office/drawing/2014/main" id="{2ECFC258-486B-435B-B2E4-832E80201BBC}"/>
               </a:ext>
             </a:extLst>
           </p:cNvPr>
@@ -7651,7 +7651,7 @@
           <p:cNvPr id="13" name="">
             <a:extLst xmlns:a="http://schemas.openxmlformats.org/drawingml/2006/main">
               <a:ext uri="{FF2B5EF4-FFF2-40B4-BE49-F238E27FC236}">
-                <a16:creationId xmlns:a16="http://schemas.microsoft.com/office/drawing/2014/main" id="{FA1BB185-E00A-4F7F-A852-50DF5ECF62A6}"/>
+                <a16:creationId xmlns:a16="http://schemas.microsoft.com/office/drawing/2014/main" id="{C4F72276-0C67-40DB-8C80-CC097083DB2E}"/>
               </a:ext>
             </a:extLst>
           </p:cNvPr>
@@ -7701,7 +7701,7 @@
           <p:cNvPr id="14" name="">
             <a:extLst xmlns:a="http://schemas.openxmlformats.org/drawingml/2006/main">
               <a:ext uri="{FF2B5EF4-FFF2-40B4-BE49-F238E27FC236}">
-                <a16:creationId xmlns:a16="http://schemas.microsoft.com/office/drawing/2014/main" id="{BB993C17-05A0-4F30-8CC8-4A5513B0C192}"/>
+                <a16:creationId xmlns:a16="http://schemas.microsoft.com/office/drawing/2014/main" id="{134458A6-F2A6-4220-8137-C3D427563319}"/>
               </a:ext>
             </a:extLst>
           </p:cNvPr>
@@ -7751,7 +7751,7 @@
           <p:cNvPr id="15" name="">
             <a:extLst xmlns:a="http://schemas.openxmlformats.org/drawingml/2006/main">
               <a:ext uri="{FF2B5EF4-FFF2-40B4-BE49-F238E27FC236}">
-                <a16:creationId xmlns:a16="http://schemas.microsoft.com/office/drawing/2014/main" id="{4675F107-3E67-4D04-98AB-B34480FF570F}"/>
+                <a16:creationId xmlns:a16="http://schemas.microsoft.com/office/drawing/2014/main" id="{D4C7D003-6925-4D21-8A38-96C3541F92EF}"/>
               </a:ext>
             </a:extLst>
           </p:cNvPr>
@@ -7784,7 +7784,7 @@
           <p:cNvPr id="16" name="">
             <a:extLst xmlns:a="http://schemas.openxmlformats.org/drawingml/2006/main">
               <a:ext uri="{FF2B5EF4-FFF2-40B4-BE49-F238E27FC236}">
-                <a16:creationId xmlns:a16="http://schemas.microsoft.com/office/drawing/2014/main" id="{FB1091CD-B67F-4EE5-A869-0865B42D1D9A}"/>
+                <a16:creationId xmlns:a16="http://schemas.microsoft.com/office/drawing/2014/main" id="{DAB62826-32BC-4F7F-B8C3-7F1B4AE7E385}"/>
               </a:ext>
             </a:extLst>
           </p:cNvPr>
@@ -7834,7 +7834,7 @@
           <p:cNvPr id="17" name="">
             <a:extLst xmlns:a="http://schemas.openxmlformats.org/drawingml/2006/main">
               <a:ext uri="{FF2B5EF4-FFF2-40B4-BE49-F238E27FC236}">
-                <a16:creationId xmlns:a16="http://schemas.microsoft.com/office/drawing/2014/main" id="{82C8588B-DB16-49C0-9C45-9DA41AA2E1BA}"/>
+                <a16:creationId xmlns:a16="http://schemas.microsoft.com/office/drawing/2014/main" id="{94EE6518-A83A-4A16-B770-2DE534F75FE0}"/>
               </a:ext>
             </a:extLst>
           </p:cNvPr>
@@ -7884,7 +7884,7 @@
           <p:cNvPr id="18" name="">
             <a:extLst xmlns:a="http://schemas.openxmlformats.org/drawingml/2006/main">
               <a:ext uri="{FF2B5EF4-FFF2-40B4-BE49-F238E27FC236}">
-                <a16:creationId xmlns:a16="http://schemas.microsoft.com/office/drawing/2014/main" id="{A009EB6D-1740-466D-801A-75DE20A57A61}"/>
+                <a16:creationId xmlns:a16="http://schemas.microsoft.com/office/drawing/2014/main" id="{6503DAD3-6EAE-4F13-B5CF-653B17A6319F}"/>
               </a:ext>
             </a:extLst>
           </p:cNvPr>
@@ -7932,7 +7932,7 @@
     </p:spTree>
     <p:extLst>
       <p:ext uri="{BB962C8B-B14F-4D97-AF65-F5344CB8AC3E}">
-        <p14:creationId xmlns:p14="http://schemas.microsoft.com/office/powerpoint/2010/main" val="900472222"/>
+        <p14:creationId xmlns:p14="http://schemas.microsoft.com/office/powerpoint/2010/main" val="1861075263"/>
       </p:ext>
     </p:extLst>
   </p:cSld>
@@ -7963,7 +7963,7 @@
           <p:cNvPr id="21" name="">
             <a:extLst xmlns:a="http://schemas.openxmlformats.org/drawingml/2006/main">
               <a:ext uri="{FF2B5EF4-FFF2-40B4-BE49-F238E27FC236}">
-                <a16:creationId xmlns:a16="http://schemas.microsoft.com/office/drawing/2014/main" id="{B10A37A5-2518-465D-86E6-B1BD26BAF608}"/>
+                <a16:creationId xmlns:a16="http://schemas.microsoft.com/office/drawing/2014/main" id="{7D3FBFFD-85BA-4C3A-B657-B240C2BD0849}"/>
               </a:ext>
             </a:extLst>
           </p:cNvPr>
@@ -8013,7 +8013,7 @@
           <p:cNvPr id="2" name="">
             <a:extLst xmlns:a="http://schemas.openxmlformats.org/drawingml/2006/main">
               <a:ext uri="{FF2B5EF4-FFF2-40B4-BE49-F238E27FC236}">
-                <a16:creationId xmlns:a16="http://schemas.microsoft.com/office/drawing/2014/main" id="{844BCF04-C495-4043-A4FB-B70BCC213FE9}"/>
+                <a16:creationId xmlns:a16="http://schemas.microsoft.com/office/drawing/2014/main" id="{7FBF7649-9AB8-4994-BFD9-AA1A5CE55520}"/>
               </a:ext>
             </a:extLst>
           </p:cNvPr>
@@ -8063,7 +8063,7 @@
           <p:cNvPr id="3" name="">
             <a:extLst xmlns:a="http://schemas.openxmlformats.org/drawingml/2006/main">
               <a:ext uri="{FF2B5EF4-FFF2-40B4-BE49-F238E27FC236}">
-                <a16:creationId xmlns:a16="http://schemas.microsoft.com/office/drawing/2014/main" id="{28A0D84C-CB23-4AA9-BFCE-23FB70503B35}"/>
+                <a16:creationId xmlns:a16="http://schemas.microsoft.com/office/drawing/2014/main" id="{5AADD675-CDDA-4104-8220-9A456630EEB1}"/>
               </a:ext>
             </a:extLst>
           </p:cNvPr>
@@ -8094,7 +8094,7 @@
           <p:cNvPr id="4" name="">
             <a:extLst xmlns:a="http://schemas.openxmlformats.org/drawingml/2006/main">
               <a:ext uri="{FF2B5EF4-FFF2-40B4-BE49-F238E27FC236}">
-                <a16:creationId xmlns:a16="http://schemas.microsoft.com/office/drawing/2014/main" id="{8A9E06FB-3D9F-480C-A507-74FD776A8162}"/>
+                <a16:creationId xmlns:a16="http://schemas.microsoft.com/office/drawing/2014/main" id="{FEB17C62-A9F7-4D2E-BE9F-5E0E20BBB534}"/>
               </a:ext>
             </a:extLst>
           </p:cNvPr>
@@ -8144,7 +8144,7 @@
           <p:cNvPr id="5" name="">
             <a:extLst xmlns:a="http://schemas.openxmlformats.org/drawingml/2006/main">
               <a:ext uri="{FF2B5EF4-FFF2-40B4-BE49-F238E27FC236}">
-                <a16:creationId xmlns:a16="http://schemas.microsoft.com/office/drawing/2014/main" id="{78000C8D-1812-43FD-9E77-32461378176B}"/>
+                <a16:creationId xmlns:a16="http://schemas.microsoft.com/office/drawing/2014/main" id="{66B96220-36D7-40D2-9E69-079A2D2E054F}"/>
               </a:ext>
             </a:extLst>
           </p:cNvPr>
@@ -8184,7 +8184,7 @@
                   <a:srgbClr val="526077"/>
                 </a:solidFill>
               </a:rPr>
-              <a:t>Testnet evidence proves the lifecycle can be signed, submitted, and independently inspected.</a:t>
+              <a:t>Product behavior is exercised through automated coverage and visible contract state changes.</a:t>
             </a:r>
           </a:p>
         </p:txBody>
@@ -8194,7 +8194,7 @@
           <p:cNvPr id="6" name="">
             <a:extLst xmlns:a="http://schemas.openxmlformats.org/drawingml/2006/main">
               <a:ext uri="{FF2B5EF4-FFF2-40B4-BE49-F238E27FC236}">
-                <a16:creationId xmlns:a16="http://schemas.microsoft.com/office/drawing/2014/main" id="{E6F21EDA-4454-4245-8511-E3082E959BCA}"/>
+                <a16:creationId xmlns:a16="http://schemas.microsoft.com/office/drawing/2014/main" id="{F28B23DB-54BB-47B6-B183-59E7CC356DB9}"/>
               </a:ext>
             </a:extLst>
           </p:cNvPr>
@@ -8227,7 +8227,7 @@
           <p:cNvPr id="7" name="">
             <a:extLst xmlns:a="http://schemas.openxmlformats.org/drawingml/2006/main">
               <a:ext uri="{FF2B5EF4-FFF2-40B4-BE49-F238E27FC236}">
-                <a16:creationId xmlns:a16="http://schemas.microsoft.com/office/drawing/2014/main" id="{F973E597-3D9B-458F-AA94-8216EC29FFDF}"/>
+                <a16:creationId xmlns:a16="http://schemas.microsoft.com/office/drawing/2014/main" id="{02007AAB-70E2-49B7-B7AB-80B69E54B028}"/>
               </a:ext>
             </a:extLst>
           </p:cNvPr>
@@ -8260,7 +8260,7 @@
           <p:cNvPr id="8" name="">
             <a:extLst xmlns:a="http://schemas.openxmlformats.org/drawingml/2006/main">
               <a:ext uri="{FF2B5EF4-FFF2-40B4-BE49-F238E27FC236}">
-                <a16:creationId xmlns:a16="http://schemas.microsoft.com/office/drawing/2014/main" id="{451392A7-2A9B-41ED-8052-99C1648407E3}"/>
+                <a16:creationId xmlns:a16="http://schemas.microsoft.com/office/drawing/2014/main" id="{3806868C-0A34-4A45-B130-1D8B3F2F8318}"/>
               </a:ext>
             </a:extLst>
           </p:cNvPr>
@@ -8300,7 +8300,7 @@
                   <a:srgbClr val="101827"/>
                 </a:solidFill>
               </a:rPr>
-              <a:t>40 / 40</a:t>
+              <a:t>TESTNET</a:t>
             </a:r>
           </a:p>
         </p:txBody>
@@ -8310,7 +8310,7 @@
           <p:cNvPr id="9" name="">
             <a:extLst xmlns:a="http://schemas.openxmlformats.org/drawingml/2006/main">
               <a:ext uri="{FF2B5EF4-FFF2-40B4-BE49-F238E27FC236}">
-                <a16:creationId xmlns:a16="http://schemas.microsoft.com/office/drawing/2014/main" id="{9B5FC49E-2AD0-4E60-8744-FD1DFD1A3835}"/>
+                <a16:creationId xmlns:a16="http://schemas.microsoft.com/office/drawing/2014/main" id="{737707AB-D7DF-46B4-A23B-E958ED5FBFD4}"/>
               </a:ext>
             </a:extLst>
           </p:cNvPr>
@@ -8350,7 +8350,7 @@
                   <a:srgbClr val="526077"/>
                 </a:solidFill>
               </a:rPr>
-              <a:t>new wallets completed a low-value post_job testnet interaction</a:t>
+              <a:t>live dApp connected to deployed EscrowContract and WorkToken</a:t>
             </a:r>
           </a:p>
         </p:txBody>
@@ -8360,7 +8360,7 @@
           <p:cNvPr id="10" name="">
             <a:extLst xmlns:a="http://schemas.openxmlformats.org/drawingml/2006/main">
               <a:ext uri="{FF2B5EF4-FFF2-40B4-BE49-F238E27FC236}">
-                <a16:creationId xmlns:a16="http://schemas.microsoft.com/office/drawing/2014/main" id="{B9C7CB8A-9016-4E7D-9D2E-53D7B9E8A3B7}"/>
+                <a16:creationId xmlns:a16="http://schemas.microsoft.com/office/drawing/2014/main" id="{A0BEFBD9-F1EE-43C1-A576-A4039452512A}"/>
               </a:ext>
             </a:extLst>
           </p:cNvPr>
@@ -8393,7 +8393,7 @@
           <p:cNvPr id="11" name="">
             <a:extLst xmlns:a="http://schemas.openxmlformats.org/drawingml/2006/main">
               <a:ext uri="{FF2B5EF4-FFF2-40B4-BE49-F238E27FC236}">
-                <a16:creationId xmlns:a16="http://schemas.microsoft.com/office/drawing/2014/main" id="{0BD633EC-1D89-4F3F-B9BD-C97690387EAB}"/>
+                <a16:creationId xmlns:a16="http://schemas.microsoft.com/office/drawing/2014/main" id="{B4A3A685-2779-4302-A780-B03C9945A393}"/>
               </a:ext>
             </a:extLst>
           </p:cNvPr>
@@ -8426,7 +8426,7 @@
           <p:cNvPr id="12" name="">
             <a:extLst xmlns:a="http://schemas.openxmlformats.org/drawingml/2006/main">
               <a:ext uri="{FF2B5EF4-FFF2-40B4-BE49-F238E27FC236}">
-                <a16:creationId xmlns:a16="http://schemas.microsoft.com/office/drawing/2014/main" id="{DE376483-D931-4846-BA67-61841DA55C23}"/>
+                <a16:creationId xmlns:a16="http://schemas.microsoft.com/office/drawing/2014/main" id="{B4E7613F-3161-4F18-996A-7D0AE70D2CFF}"/>
               </a:ext>
             </a:extLst>
           </p:cNvPr>
@@ -8466,7 +8466,7 @@
                   <a:srgbClr val="101827"/>
                 </a:solidFill>
               </a:rPr>
-              <a:t>50</a:t>
+              <a:t>ON-CHAIN</a:t>
             </a:r>
           </a:p>
         </p:txBody>
@@ -8476,7 +8476,7 @@
           <p:cNvPr id="13" name="">
             <a:extLst xmlns:a="http://schemas.openxmlformats.org/drawingml/2006/main">
               <a:ext uri="{FF2B5EF4-FFF2-40B4-BE49-F238E27FC236}">
-                <a16:creationId xmlns:a16="http://schemas.microsoft.com/office/drawing/2014/main" id="{4BC835FD-A779-46EC-BFA0-9C4CB179CDC5}"/>
+                <a16:creationId xmlns:a16="http://schemas.microsoft.com/office/drawing/2014/main" id="{FA66D458-7A1C-4EA1-9A62-A55D591C15D8}"/>
               </a:ext>
             </a:extLst>
           </p:cNvPr>
@@ -8516,7 +8516,7 @@
                   <a:srgbClr val="526077"/>
                 </a:solidFill>
               </a:rPr>
-              <a:t>distinct wallets selected for the combined submission cohort</a:t>
+              <a:t>critical contract state changes are signed and independently inspectable</a:t>
             </a:r>
           </a:p>
         </p:txBody>
@@ -8526,7 +8526,7 @@
           <p:cNvPr id="14" name="">
             <a:extLst xmlns:a="http://schemas.openxmlformats.org/drawingml/2006/main">
               <a:ext uri="{FF2B5EF4-FFF2-40B4-BE49-F238E27FC236}">
-                <a16:creationId xmlns:a16="http://schemas.microsoft.com/office/drawing/2014/main" id="{CADA7D68-D108-479A-9296-89D9D915F522}"/>
+                <a16:creationId xmlns:a16="http://schemas.microsoft.com/office/drawing/2014/main" id="{6E0911C5-1B82-42FC-A662-EDAC7AE05DE8}"/>
               </a:ext>
             </a:extLst>
           </p:cNvPr>
@@ -8559,7 +8559,7 @@
           <p:cNvPr id="15" name="">
             <a:extLst xmlns:a="http://schemas.openxmlformats.org/drawingml/2006/main">
               <a:ext uri="{FF2B5EF4-FFF2-40B4-BE49-F238E27FC236}">
-                <a16:creationId xmlns:a16="http://schemas.microsoft.com/office/drawing/2014/main" id="{EAB1BA01-E5FF-4D40-B522-2B7B34DF652C}"/>
+                <a16:creationId xmlns:a16="http://schemas.microsoft.com/office/drawing/2014/main" id="{CF662DF4-1B19-4F15-AD39-29A5874AA695}"/>
               </a:ext>
             </a:extLst>
           </p:cNvPr>
@@ -8592,7 +8592,7 @@
           <p:cNvPr id="16" name="">
             <a:extLst xmlns:a="http://schemas.openxmlformats.org/drawingml/2006/main">
               <a:ext uri="{FF2B5EF4-FFF2-40B4-BE49-F238E27FC236}">
-                <a16:creationId xmlns:a16="http://schemas.microsoft.com/office/drawing/2014/main" id="{C69FB291-9D14-4C95-B12E-D776C304064D}"/>
+                <a16:creationId xmlns:a16="http://schemas.microsoft.com/office/drawing/2014/main" id="{A8192E77-7564-4D86-AB7D-4501A34B7DDE}"/>
               </a:ext>
             </a:extLst>
           </p:cNvPr>
@@ -8642,7 +8642,7 @@
           <p:cNvPr id="17" name="">
             <a:extLst xmlns:a="http://schemas.openxmlformats.org/drawingml/2006/main">
               <a:ext uri="{FF2B5EF4-FFF2-40B4-BE49-F238E27FC236}">
-                <a16:creationId xmlns:a16="http://schemas.microsoft.com/office/drawing/2014/main" id="{AA4E4FD3-2201-4F97-A44A-BF85D6009B41}"/>
+                <a16:creationId xmlns:a16="http://schemas.microsoft.com/office/drawing/2014/main" id="{34FB6E94-9D8E-441C-A927-9F6DE81EDA98}"/>
               </a:ext>
             </a:extLst>
           </p:cNvPr>
@@ -8692,7 +8692,7 @@
           <p:cNvPr id="18" name="">
             <a:extLst xmlns:a="http://schemas.openxmlformats.org/drawingml/2006/main">
               <a:ext uri="{FF2B5EF4-FFF2-40B4-BE49-F238E27FC236}">
-                <a16:creationId xmlns:a16="http://schemas.microsoft.com/office/drawing/2014/main" id="{1CE2AAEF-5269-4D08-B001-34BE3B3A427F}"/>
+                <a16:creationId xmlns:a16="http://schemas.microsoft.com/office/drawing/2014/main" id="{4200C659-5E62-423D-AD8B-E536BB9E5BD1}"/>
               </a:ext>
             </a:extLst>
           </p:cNvPr>
@@ -8725,7 +8725,7 @@
           <p:cNvPr id="19" name="">
             <a:extLst xmlns:a="http://schemas.openxmlformats.org/drawingml/2006/main">
               <a:ext uri="{FF2B5EF4-FFF2-40B4-BE49-F238E27FC236}">
-                <a16:creationId xmlns:a16="http://schemas.microsoft.com/office/drawing/2014/main" id="{B3D5BB43-B9D7-4574-96CA-4D4E62F2BC05}"/>
+                <a16:creationId xmlns:a16="http://schemas.microsoft.com/office/drawing/2014/main" id="{BCE30756-9D0B-494B-A8BE-E432DCCB3761}"/>
               </a:ext>
             </a:extLst>
           </p:cNvPr>
@@ -8765,7 +8765,7 @@
                   <a:srgbClr val="101827"/>
                 </a:solidFill>
               </a:rPr>
-              <a:t>Live testnet dApp + deployed EscrowContract and WorkToken. Testnet validation is not presented as human feedback.</a:t>
+              <a:t>Product validation combines clear on-chain visibility with automated contract coverage.</a:t>
             </a:r>
           </a:p>
         </p:txBody>
@@ -8775,7 +8775,7 @@
           <p:cNvPr id="20" name="">
             <a:extLst xmlns:a="http://schemas.openxmlformats.org/drawingml/2006/main">
               <a:ext uri="{FF2B5EF4-FFF2-40B4-BE49-F238E27FC236}">
-                <a16:creationId xmlns:a16="http://schemas.microsoft.com/office/drawing/2014/main" id="{67B5CE6E-CD1C-47C9-8F3F-C33B9AA1CFB5}"/>
+                <a16:creationId xmlns:a16="http://schemas.microsoft.com/office/drawing/2014/main" id="{EE84F931-9C4C-4EAF-960B-C046638C686D}"/>
               </a:ext>
             </a:extLst>
           </p:cNvPr>
@@ -8823,7 +8823,7 @@
     </p:spTree>
     <p:extLst>
       <p:ext uri="{BB962C8B-B14F-4D97-AF65-F5344CB8AC3E}">
-        <p14:creationId xmlns:p14="http://schemas.microsoft.com/office/powerpoint/2010/main" val="1986885296"/>
+        <p14:creationId xmlns:p14="http://schemas.microsoft.com/office/powerpoint/2010/main" val="2041323175"/>
       </p:ext>
     </p:extLst>
   </p:cSld>
@@ -8854,7 +8854,7 @@
           <p:cNvPr id="22" name="">
             <a:extLst xmlns:a="http://schemas.openxmlformats.org/drawingml/2006/main">
               <a:ext uri="{FF2B5EF4-FFF2-40B4-BE49-F238E27FC236}">
-                <a16:creationId xmlns:a16="http://schemas.microsoft.com/office/drawing/2014/main" id="{0A49D40E-8589-4048-AE7C-65534CD7460B}"/>
+                <a16:creationId xmlns:a16="http://schemas.microsoft.com/office/drawing/2014/main" id="{CCFAF055-323E-4010-89D4-24D87B312AA8}"/>
               </a:ext>
             </a:extLst>
           </p:cNvPr>
@@ -8904,7 +8904,7 @@
           <p:cNvPr id="2" name="">
             <a:extLst xmlns:a="http://schemas.openxmlformats.org/drawingml/2006/main">
               <a:ext uri="{FF2B5EF4-FFF2-40B4-BE49-F238E27FC236}">
-                <a16:creationId xmlns:a16="http://schemas.microsoft.com/office/drawing/2014/main" id="{897F599E-9304-46A1-B9CE-7E9BEBC7D213}"/>
+                <a16:creationId xmlns:a16="http://schemas.microsoft.com/office/drawing/2014/main" id="{66CD7227-A6C5-4485-8033-400425E1E317}"/>
               </a:ext>
             </a:extLst>
           </p:cNvPr>
@@ -8954,7 +8954,7 @@
           <p:cNvPr id="3" name="">
             <a:extLst xmlns:a="http://schemas.openxmlformats.org/drawingml/2006/main">
               <a:ext uri="{FF2B5EF4-FFF2-40B4-BE49-F238E27FC236}">
-                <a16:creationId xmlns:a16="http://schemas.microsoft.com/office/drawing/2014/main" id="{BC99AA6E-0420-4214-B6B9-5588C439AC34}"/>
+                <a16:creationId xmlns:a16="http://schemas.microsoft.com/office/drawing/2014/main" id="{E6E1C030-2B49-4999-A4EA-D36A66123418}"/>
               </a:ext>
             </a:extLst>
           </p:cNvPr>
@@ -8985,7 +8985,7 @@
           <p:cNvPr id="4" name="">
             <a:extLst xmlns:a="http://schemas.openxmlformats.org/drawingml/2006/main">
               <a:ext uri="{FF2B5EF4-FFF2-40B4-BE49-F238E27FC236}">
-                <a16:creationId xmlns:a16="http://schemas.microsoft.com/office/drawing/2014/main" id="{8F8D3126-8520-424F-95D9-B34F031ED28D}"/>
+                <a16:creationId xmlns:a16="http://schemas.microsoft.com/office/drawing/2014/main" id="{C509D82E-AAF7-4AF8-903F-031581EAD288}"/>
               </a:ext>
             </a:extLst>
           </p:cNvPr>
@@ -9035,7 +9035,7 @@
           <p:cNvPr id="5" name="">
             <a:extLst xmlns:a="http://schemas.openxmlformats.org/drawingml/2006/main">
               <a:ext uri="{FF2B5EF4-FFF2-40B4-BE49-F238E27FC236}">
-                <a16:creationId xmlns:a16="http://schemas.microsoft.com/office/drawing/2014/main" id="{380BDA63-EE1C-4D51-8940-AA4C0C4E1CCC}"/>
+                <a16:creationId xmlns:a16="http://schemas.microsoft.com/office/drawing/2014/main" id="{F4C90BCD-B71A-4D1E-B2AB-E4A373FC4F2F}"/>
               </a:ext>
             </a:extLst>
           </p:cNvPr>
@@ -9085,7 +9085,7 @@
           <p:cNvPr id="6" name="">
             <a:extLst xmlns:a="http://schemas.openxmlformats.org/drawingml/2006/main">
               <a:ext uri="{FF2B5EF4-FFF2-40B4-BE49-F238E27FC236}">
-                <a16:creationId xmlns:a16="http://schemas.microsoft.com/office/drawing/2014/main" id="{342F1C68-B6EB-4528-B87B-91D050453199}"/>
+                <a16:creationId xmlns:a16="http://schemas.microsoft.com/office/drawing/2014/main" id="{9467C37B-3B0E-4537-8D43-5DB9C03F100B}"/>
               </a:ext>
             </a:extLst>
           </p:cNvPr>
@@ -9120,7 +9120,7 @@
           <p:cNvPr id="7" name="">
             <a:extLst xmlns:a="http://schemas.openxmlformats.org/drawingml/2006/main">
               <a:ext uri="{FF2B5EF4-FFF2-40B4-BE49-F238E27FC236}">
-                <a16:creationId xmlns:a16="http://schemas.microsoft.com/office/drawing/2014/main" id="{779D8757-B031-4000-84B4-2EA8B82DF929}"/>
+                <a16:creationId xmlns:a16="http://schemas.microsoft.com/office/drawing/2014/main" id="{C7789067-2ACA-409B-A65A-EFD2AD840231}"/>
               </a:ext>
             </a:extLst>
           </p:cNvPr>
@@ -9153,7 +9153,7 @@
           <p:cNvPr id="8" name="">
             <a:extLst xmlns:a="http://schemas.openxmlformats.org/drawingml/2006/main">
               <a:ext uri="{FF2B5EF4-FFF2-40B4-BE49-F238E27FC236}">
-                <a16:creationId xmlns:a16="http://schemas.microsoft.com/office/drawing/2014/main" id="{10CDC295-BAA4-4784-A994-9EEE2990A754}"/>
+                <a16:creationId xmlns:a16="http://schemas.microsoft.com/office/drawing/2014/main" id="{C6482697-8625-434F-8FA0-B9DE18EDE860}"/>
               </a:ext>
             </a:extLst>
           </p:cNvPr>
@@ -9203,7 +9203,7 @@
           <p:cNvPr id="9" name="">
             <a:extLst xmlns:a="http://schemas.openxmlformats.org/drawingml/2006/main">
               <a:ext uri="{FF2B5EF4-FFF2-40B4-BE49-F238E27FC236}">
-                <a16:creationId xmlns:a16="http://schemas.microsoft.com/office/drawing/2014/main" id="{26A71360-00B3-4975-B618-761F042EB916}"/>
+                <a16:creationId xmlns:a16="http://schemas.microsoft.com/office/drawing/2014/main" id="{C6A9FE29-B229-4AB4-B764-688EA56DD546}"/>
               </a:ext>
             </a:extLst>
           </p:cNvPr>
@@ -9253,7 +9253,7 @@
           <p:cNvPr id="10" name="">
             <a:extLst xmlns:a="http://schemas.openxmlformats.org/drawingml/2006/main">
               <a:ext uri="{FF2B5EF4-FFF2-40B4-BE49-F238E27FC236}">
-                <a16:creationId xmlns:a16="http://schemas.microsoft.com/office/drawing/2014/main" id="{CFC1060F-56FA-48CF-84E1-DD3F76F3ADA0}"/>
+                <a16:creationId xmlns:a16="http://schemas.microsoft.com/office/drawing/2014/main" id="{0E837857-5793-4381-86A2-3615C3AB0567}"/>
               </a:ext>
             </a:extLst>
           </p:cNvPr>
@@ -9303,7 +9303,7 @@
           <p:cNvPr id="11" name="">
             <a:extLst xmlns:a="http://schemas.openxmlformats.org/drawingml/2006/main">
               <a:ext uri="{FF2B5EF4-FFF2-40B4-BE49-F238E27FC236}">
-                <a16:creationId xmlns:a16="http://schemas.microsoft.com/office/drawing/2014/main" id="{8C791880-E4DA-4392-86C5-D6D662165F1A}"/>
+                <a16:creationId xmlns:a16="http://schemas.microsoft.com/office/drawing/2014/main" id="{BB83585D-0A5B-4805-864F-7CED05169753}"/>
               </a:ext>
             </a:extLst>
           </p:cNvPr>
@@ -9338,7 +9338,7 @@
           <p:cNvPr id="12" name="">
             <a:extLst xmlns:a="http://schemas.openxmlformats.org/drawingml/2006/main">
               <a:ext uri="{FF2B5EF4-FFF2-40B4-BE49-F238E27FC236}">
-                <a16:creationId xmlns:a16="http://schemas.microsoft.com/office/drawing/2014/main" id="{1E5248FB-F3D6-4D9E-B33D-F94BD9F61E46}"/>
+                <a16:creationId xmlns:a16="http://schemas.microsoft.com/office/drawing/2014/main" id="{8D3198E5-585E-4EB1-941E-9B7493307C0A}"/>
               </a:ext>
             </a:extLst>
           </p:cNvPr>
@@ -9371,7 +9371,7 @@
           <p:cNvPr id="13" name="">
             <a:extLst xmlns:a="http://schemas.openxmlformats.org/drawingml/2006/main">
               <a:ext uri="{FF2B5EF4-FFF2-40B4-BE49-F238E27FC236}">
-                <a16:creationId xmlns:a16="http://schemas.microsoft.com/office/drawing/2014/main" id="{0AF2AC82-18DC-4F86-84C0-AC7A3AF16D36}"/>
+                <a16:creationId xmlns:a16="http://schemas.microsoft.com/office/drawing/2014/main" id="{6641D62B-4A36-428E-9B1B-9194B3B32D35}"/>
               </a:ext>
             </a:extLst>
           </p:cNvPr>
@@ -9421,7 +9421,7 @@
           <p:cNvPr id="14" name="">
             <a:extLst xmlns:a="http://schemas.openxmlformats.org/drawingml/2006/main">
               <a:ext uri="{FF2B5EF4-FFF2-40B4-BE49-F238E27FC236}">
-                <a16:creationId xmlns:a16="http://schemas.microsoft.com/office/drawing/2014/main" id="{9A886F02-530C-4BF9-B70A-486189982368}"/>
+                <a16:creationId xmlns:a16="http://schemas.microsoft.com/office/drawing/2014/main" id="{5AA48ABB-4120-4953-B839-226A76A8DF61}"/>
               </a:ext>
             </a:extLst>
           </p:cNvPr>
@@ -9471,7 +9471,7 @@
           <p:cNvPr id="15" name="">
             <a:extLst xmlns:a="http://schemas.openxmlformats.org/drawingml/2006/main">
               <a:ext uri="{FF2B5EF4-FFF2-40B4-BE49-F238E27FC236}">
-                <a16:creationId xmlns:a16="http://schemas.microsoft.com/office/drawing/2014/main" id="{6D613A01-6F6B-4A07-B2E4-B9C21FB7DACB}"/>
+                <a16:creationId xmlns:a16="http://schemas.microsoft.com/office/drawing/2014/main" id="{3FB93065-DC97-4FB0-AF95-B0C854C575A0}"/>
               </a:ext>
             </a:extLst>
           </p:cNvPr>
@@ -9521,7 +9521,7 @@
           <p:cNvPr id="16" name="">
             <a:extLst xmlns:a="http://schemas.openxmlformats.org/drawingml/2006/main">
               <a:ext uri="{FF2B5EF4-FFF2-40B4-BE49-F238E27FC236}">
-                <a16:creationId xmlns:a16="http://schemas.microsoft.com/office/drawing/2014/main" id="{B2A3862B-7B6F-44B7-B49D-E700DDC84062}"/>
+                <a16:creationId xmlns:a16="http://schemas.microsoft.com/office/drawing/2014/main" id="{E5600CD7-3F2D-4A82-A1AB-7325EFADCF82}"/>
               </a:ext>
             </a:extLst>
           </p:cNvPr>
@@ -9556,7 +9556,7 @@
           <p:cNvPr id="17" name="">
             <a:extLst xmlns:a="http://schemas.openxmlformats.org/drawingml/2006/main">
               <a:ext uri="{FF2B5EF4-FFF2-40B4-BE49-F238E27FC236}">
-                <a16:creationId xmlns:a16="http://schemas.microsoft.com/office/drawing/2014/main" id="{39058F4D-AB3E-4601-A14A-69E5D940E4CD}"/>
+                <a16:creationId xmlns:a16="http://schemas.microsoft.com/office/drawing/2014/main" id="{DA1A13FD-35A3-493F-BBD9-A80E06938810}"/>
               </a:ext>
             </a:extLst>
           </p:cNvPr>
@@ -9589,7 +9589,7 @@
           <p:cNvPr id="18" name="">
             <a:extLst xmlns:a="http://schemas.openxmlformats.org/drawingml/2006/main">
               <a:ext uri="{FF2B5EF4-FFF2-40B4-BE49-F238E27FC236}">
-                <a16:creationId xmlns:a16="http://schemas.microsoft.com/office/drawing/2014/main" id="{95F0A29C-3526-47BE-8754-3FCE2D283465}"/>
+                <a16:creationId xmlns:a16="http://schemas.microsoft.com/office/drawing/2014/main" id="{B5AE768D-6B1C-40E0-B637-2B23593FEBBE}"/>
               </a:ext>
             </a:extLst>
           </p:cNvPr>
@@ -9639,7 +9639,7 @@
           <p:cNvPr id="19" name="">
             <a:extLst xmlns:a="http://schemas.openxmlformats.org/drawingml/2006/main">
               <a:ext uri="{FF2B5EF4-FFF2-40B4-BE49-F238E27FC236}">
-                <a16:creationId xmlns:a16="http://schemas.microsoft.com/office/drawing/2014/main" id="{95A7E071-0BDA-4604-838B-1E39229138CA}"/>
+                <a16:creationId xmlns:a16="http://schemas.microsoft.com/office/drawing/2014/main" id="{FB6FDDD2-906A-4A5D-BEAE-C8617A903D5C}"/>
               </a:ext>
             </a:extLst>
           </p:cNvPr>
@@ -9689,7 +9689,7 @@
           <p:cNvPr id="20" name="">
             <a:extLst xmlns:a="http://schemas.openxmlformats.org/drawingml/2006/main">
               <a:ext uri="{FF2B5EF4-FFF2-40B4-BE49-F238E27FC236}">
-                <a16:creationId xmlns:a16="http://schemas.microsoft.com/office/drawing/2014/main" id="{BB2474BC-C21B-4B1B-BEDA-8011FB293355}"/>
+                <a16:creationId xmlns:a16="http://schemas.microsoft.com/office/drawing/2014/main" id="{D392C81F-ED7F-454A-90E8-883390A95D15}"/>
               </a:ext>
             </a:extLst>
           </p:cNvPr>
@@ -9739,7 +9739,7 @@
           <p:cNvPr id="21" name="">
             <a:extLst xmlns:a="http://schemas.openxmlformats.org/drawingml/2006/main">
               <a:ext uri="{FF2B5EF4-FFF2-40B4-BE49-F238E27FC236}">
-                <a16:creationId xmlns:a16="http://schemas.microsoft.com/office/drawing/2014/main" id="{112EF054-8CC8-433F-BF19-2D539938D2A2}"/>
+                <a16:creationId xmlns:a16="http://schemas.microsoft.com/office/drawing/2014/main" id="{5D3AEE22-66A7-43EC-8FC0-E347857A3348}"/>
               </a:ext>
             </a:extLst>
           </p:cNvPr>
@@ -9787,7 +9787,7 @@
     </p:spTree>
     <p:extLst>
       <p:ext uri="{BB962C8B-B14F-4D97-AF65-F5344CB8AC3E}">
-        <p14:creationId xmlns:p14="http://schemas.microsoft.com/office/powerpoint/2010/main" val="1480234807"/>
+        <p14:creationId xmlns:p14="http://schemas.microsoft.com/office/powerpoint/2010/main" val="1788157690"/>
       </p:ext>
     </p:extLst>
   </p:cSld>
@@ -9818,7 +9818,7 @@
           <p:cNvPr id="16" name="">
             <a:extLst xmlns:a="http://schemas.openxmlformats.org/drawingml/2006/main">
               <a:ext uri="{FF2B5EF4-FFF2-40B4-BE49-F238E27FC236}">
-                <a16:creationId xmlns:a16="http://schemas.microsoft.com/office/drawing/2014/main" id="{203A2E01-1B0C-4837-9F6F-04A1919A15F2}"/>
+                <a16:creationId xmlns:a16="http://schemas.microsoft.com/office/drawing/2014/main" id="{64BA7C0D-07DD-426D-B252-E5B8861B9CE3}"/>
               </a:ext>
             </a:extLst>
           </p:cNvPr>
@@ -9868,7 +9868,7 @@
           <p:cNvPr id="2" name="">
             <a:extLst xmlns:a="http://schemas.openxmlformats.org/drawingml/2006/main">
               <a:ext uri="{FF2B5EF4-FFF2-40B4-BE49-F238E27FC236}">
-                <a16:creationId xmlns:a16="http://schemas.microsoft.com/office/drawing/2014/main" id="{0EBB9542-6E7A-4E35-98CB-F5C0E5EBFF0D}"/>
+                <a16:creationId xmlns:a16="http://schemas.microsoft.com/office/drawing/2014/main" id="{6755A751-CCFC-405E-BBC3-C8B83D67898C}"/>
               </a:ext>
             </a:extLst>
           </p:cNvPr>
@@ -9918,7 +9918,7 @@
           <p:cNvPr id="3" name="">
             <a:extLst xmlns:a="http://schemas.openxmlformats.org/drawingml/2006/main">
               <a:ext uri="{FF2B5EF4-FFF2-40B4-BE49-F238E27FC236}">
-                <a16:creationId xmlns:a16="http://schemas.microsoft.com/office/drawing/2014/main" id="{B6E9D6A9-B357-48EA-B8F5-A797C73FB38B}"/>
+                <a16:creationId xmlns:a16="http://schemas.microsoft.com/office/drawing/2014/main" id="{35652931-1A7A-4995-8A39-2CDEA2BEC6F0}"/>
               </a:ext>
             </a:extLst>
           </p:cNvPr>
@@ -9949,7 +9949,7 @@
           <p:cNvPr id="4" name="">
             <a:extLst xmlns:a="http://schemas.openxmlformats.org/drawingml/2006/main">
               <a:ext uri="{FF2B5EF4-FFF2-40B4-BE49-F238E27FC236}">
-                <a16:creationId xmlns:a16="http://schemas.microsoft.com/office/drawing/2014/main" id="{5ECF1E37-1343-4E94-96B8-76834D96A64D}"/>
+                <a16:creationId xmlns:a16="http://schemas.microsoft.com/office/drawing/2014/main" id="{3ECF22A8-E8D9-4616-9714-6DEEBF9969A7}"/>
               </a:ext>
             </a:extLst>
           </p:cNvPr>
@@ -9999,7 +9999,7 @@
           <p:cNvPr id="5" name="">
             <a:extLst xmlns:a="http://schemas.openxmlformats.org/drawingml/2006/main">
               <a:ext uri="{FF2B5EF4-FFF2-40B4-BE49-F238E27FC236}">
-                <a16:creationId xmlns:a16="http://schemas.microsoft.com/office/drawing/2014/main" id="{1367371B-196C-4074-A9F7-33F6B85950FF}"/>
+                <a16:creationId xmlns:a16="http://schemas.microsoft.com/office/drawing/2014/main" id="{5D61C275-C358-413C-8DEF-2C4417963C4F}"/>
               </a:ext>
             </a:extLst>
           </p:cNvPr>
@@ -10049,7 +10049,7 @@
           <p:cNvPr id="6" name="">
             <a:extLst xmlns:a="http://schemas.openxmlformats.org/drawingml/2006/main">
               <a:ext uri="{FF2B5EF4-FFF2-40B4-BE49-F238E27FC236}">
-                <a16:creationId xmlns:a16="http://schemas.microsoft.com/office/drawing/2014/main" id="{E3A1AF73-9BD4-4032-B192-4B0FAE2A0DC2}"/>
+                <a16:creationId xmlns:a16="http://schemas.microsoft.com/office/drawing/2014/main" id="{76246857-A5D9-4BBC-89AE-A28FF14B535D}"/>
               </a:ext>
             </a:extLst>
           </p:cNvPr>
@@ -10082,7 +10082,7 @@
           <p:cNvPr id="7" name="">
             <a:extLst xmlns:a="http://schemas.openxmlformats.org/drawingml/2006/main">
               <a:ext uri="{FF2B5EF4-FFF2-40B4-BE49-F238E27FC236}">
-                <a16:creationId xmlns:a16="http://schemas.microsoft.com/office/drawing/2014/main" id="{80EA9726-64B5-4018-B6B2-F1F44D72FDBA}"/>
+                <a16:creationId xmlns:a16="http://schemas.microsoft.com/office/drawing/2014/main" id="{20AC0AD0-6C87-4484-8D80-9D0471FF486B}"/>
               </a:ext>
             </a:extLst>
           </p:cNvPr>
@@ -10132,7 +10132,7 @@
           <p:cNvPr id="8" name="">
             <a:extLst xmlns:a="http://schemas.openxmlformats.org/drawingml/2006/main">
               <a:ext uri="{FF2B5EF4-FFF2-40B4-BE49-F238E27FC236}">
-                <a16:creationId xmlns:a16="http://schemas.microsoft.com/office/drawing/2014/main" id="{0F0FDDCA-917D-4EE9-8EE3-9CF6141CD68D}"/>
+                <a16:creationId xmlns:a16="http://schemas.microsoft.com/office/drawing/2014/main" id="{014EEC30-0488-437C-8B1E-7638DF236909}"/>
               </a:ext>
             </a:extLst>
           </p:cNvPr>
@@ -10182,7 +10182,7 @@
           <p:cNvPr id="9" name="">
             <a:extLst xmlns:a="http://schemas.openxmlformats.org/drawingml/2006/main">
               <a:ext uri="{FF2B5EF4-FFF2-40B4-BE49-F238E27FC236}">
-                <a16:creationId xmlns:a16="http://schemas.microsoft.com/office/drawing/2014/main" id="{B290EA7A-CE92-4CDB-B2B1-579ED31E5240}"/>
+                <a16:creationId xmlns:a16="http://schemas.microsoft.com/office/drawing/2014/main" id="{A38B282B-9BE9-474B-99B9-20D57D7DB601}"/>
               </a:ext>
             </a:extLst>
           </p:cNvPr>
@@ -10215,7 +10215,7 @@
           <p:cNvPr id="10" name="">
             <a:extLst xmlns:a="http://schemas.openxmlformats.org/drawingml/2006/main">
               <a:ext uri="{FF2B5EF4-FFF2-40B4-BE49-F238E27FC236}">
-                <a16:creationId xmlns:a16="http://schemas.microsoft.com/office/drawing/2014/main" id="{C767AB95-04D8-45AD-94B6-75F5A6BDE747}"/>
+                <a16:creationId xmlns:a16="http://schemas.microsoft.com/office/drawing/2014/main" id="{F006555F-A9FC-4193-981B-C6139CE5D0F4}"/>
               </a:ext>
             </a:extLst>
           </p:cNvPr>
@@ -10265,7 +10265,7 @@
           <p:cNvPr id="11" name="">
             <a:extLst xmlns:a="http://schemas.openxmlformats.org/drawingml/2006/main">
               <a:ext uri="{FF2B5EF4-FFF2-40B4-BE49-F238E27FC236}">
-                <a16:creationId xmlns:a16="http://schemas.microsoft.com/office/drawing/2014/main" id="{C9C8153C-3858-4F9B-A9F0-22999E263DCC}"/>
+                <a16:creationId xmlns:a16="http://schemas.microsoft.com/office/drawing/2014/main" id="{014AC846-8307-4863-ADCF-5B262F77BCBF}"/>
               </a:ext>
             </a:extLst>
           </p:cNvPr>
@@ -10315,7 +10315,7 @@
           <p:cNvPr id="12" name="">
             <a:extLst xmlns:a="http://schemas.openxmlformats.org/drawingml/2006/main">
               <a:ext uri="{FF2B5EF4-FFF2-40B4-BE49-F238E27FC236}">
-                <a16:creationId xmlns:a16="http://schemas.microsoft.com/office/drawing/2014/main" id="{799B8FB2-5D2B-47E1-9DED-AE01E6D02F25}"/>
+                <a16:creationId xmlns:a16="http://schemas.microsoft.com/office/drawing/2014/main" id="{0DA65083-9A65-4C6C-A7A0-6B8B2AAE5904}"/>
               </a:ext>
             </a:extLst>
           </p:cNvPr>
@@ -10348,7 +10348,7 @@
           <p:cNvPr id="13" name="">
             <a:extLst xmlns:a="http://schemas.openxmlformats.org/drawingml/2006/main">
               <a:ext uri="{FF2B5EF4-FFF2-40B4-BE49-F238E27FC236}">
-                <a16:creationId xmlns:a16="http://schemas.microsoft.com/office/drawing/2014/main" id="{EC9E1444-6376-4107-A70C-87A3CF88B274}"/>
+                <a16:creationId xmlns:a16="http://schemas.microsoft.com/office/drawing/2014/main" id="{83457D18-A13A-422E-9226-BA8BB486F541}"/>
               </a:ext>
             </a:extLst>
           </p:cNvPr>
@@ -10398,7 +10398,7 @@
           <p:cNvPr id="14" name="">
             <a:extLst xmlns:a="http://schemas.openxmlformats.org/drawingml/2006/main">
               <a:ext uri="{FF2B5EF4-FFF2-40B4-BE49-F238E27FC236}">
-                <a16:creationId xmlns:a16="http://schemas.microsoft.com/office/drawing/2014/main" id="{9AF94D09-5C0A-4AEF-8921-09CCD8BA15C1}"/>
+                <a16:creationId xmlns:a16="http://schemas.microsoft.com/office/drawing/2014/main" id="{7D76C5B1-21DD-439A-A9EB-0D848A7FA423}"/>
               </a:ext>
             </a:extLst>
           </p:cNvPr>
@@ -10448,7 +10448,7 @@
           <p:cNvPr id="15" name="">
             <a:extLst xmlns:a="http://schemas.openxmlformats.org/drawingml/2006/main">
               <a:ext uri="{FF2B5EF4-FFF2-40B4-BE49-F238E27FC236}">
-                <a16:creationId xmlns:a16="http://schemas.microsoft.com/office/drawing/2014/main" id="{8FBD4D74-56A6-4CA8-B4BD-DD1018820835}"/>
+                <a16:creationId xmlns:a16="http://schemas.microsoft.com/office/drawing/2014/main" id="{DDF807A0-4FF0-419B-BF97-BE6B2CB455CA}"/>
               </a:ext>
             </a:extLst>
           </p:cNvPr>
@@ -10496,7 +10496,7 @@
     </p:spTree>
     <p:extLst>
       <p:ext uri="{BB962C8B-B14F-4D97-AF65-F5344CB8AC3E}">
-        <p14:creationId xmlns:p14="http://schemas.microsoft.com/office/powerpoint/2010/main" val="1326418882"/>
+        <p14:creationId xmlns:p14="http://schemas.microsoft.com/office/powerpoint/2010/main" val="382620427"/>
       </p:ext>
     </p:extLst>
   </p:cSld>

</xml_diff>